<commit_message>
Update PersonaForge final hackathon submission deck
Replace the existing presentation at the same path with the final seven-slide submission deck and its embedded 106-second build and runtime demo.

Include the current native CLI commands, measured comparison results, and completed hackathon summary. Use Arial fonts without embedded font data for PowerPoint portability.

Update only the PPT; do not include the recording MP4, presentation scripts, guides, or unrelated implementation changes.
</commit_message>
<xml_diff>
--- a/personaforge/presentation/PersonaForge-OCP-Hackathon-2026.pptx
+++ b/personaforge/presentation/PersonaForge-OCP-Hackathon-2026.pptx
@@ -1,6 +1,6 @@
 
 <file path=ppt/presentation.xml><?xml version="1.0" encoding="utf-8"?>
-<p:presentation xmlns:a="http://schemas.openxmlformats.org/drawingml/2006/main" xmlns:r="http://schemas.openxmlformats.org/officeDocument/2006/relationships" xmlns:p="http://schemas.openxmlformats.org/presentationml/2006/main" showSpecialPlsOnTitleSld="0" embedTrueTypeFonts="1" autoCompressPictures="0">
+<p:presentation xmlns:a="http://schemas.openxmlformats.org/drawingml/2006/main" xmlns:r="http://schemas.openxmlformats.org/officeDocument/2006/relationships" xmlns:p="http://schemas.openxmlformats.org/presentationml/2006/main" showSpecialPlsOnTitleSld="0" embedTrueTypeFonts="0" autoCompressPictures="0">
   <p:sldMasterIdLst>
     <p:sldMasterId id="2147483648" r:id="rId1"/>
   </p:sldMasterIdLst>
@@ -18,15 +18,6 @@
   </p:sldIdLst>
   <p:sldSz cx="12192000" cy="6858000"/>
   <p:notesSz cx="6858000" cy="9144000"/>
-  <p:embeddedFontLst>
-    <p:embeddedFont>
-      <p:font typeface="OpenAI Sans" panose="020B0004030202060203" pitchFamily="34" charset="77"/>
-      <p:regular r:id="rId29"/>
-      <p:bold r:id="rId30"/>
-      <p:italic r:id="rId31"/>
-      <p:boldItalic r:id="rId32"/>
-    </p:embeddedFont>
-  </p:embeddedFontLst>
   <p:defaultTextStyle>
     <a:defPPr>
       <a:defRPr lang="en-US"/>
@@ -36,9 +27,9 @@
         <a:solidFill>
           <a:schemeClr val="tx1"/>
         </a:solidFill>
-        <a:latin typeface="+mn-lt"/>
-        <a:ea typeface="+mn-ea"/>
-        <a:cs typeface="+mn-cs"/>
+        <a:latin typeface="Arial"/>
+        <a:ea typeface="Arial"/>
+        <a:cs typeface="Arial"/>
       </a:defRPr>
     </a:lvl1pPr>
     <a:lvl2pPr marL="457200" algn="l" defTabSz="914400" rtl="0" eaLnBrk="1" latinLnBrk="0" hangingPunct="1">
@@ -46,9 +37,9 @@
         <a:solidFill>
           <a:schemeClr val="tx1"/>
         </a:solidFill>
-        <a:latin typeface="+mn-lt"/>
-        <a:ea typeface="+mn-ea"/>
-        <a:cs typeface="+mn-cs"/>
+        <a:latin typeface="Arial"/>
+        <a:ea typeface="Arial"/>
+        <a:cs typeface="Arial"/>
       </a:defRPr>
     </a:lvl2pPr>
     <a:lvl3pPr marL="914400" algn="l" defTabSz="914400" rtl="0" eaLnBrk="1" latinLnBrk="0" hangingPunct="1">
@@ -56,9 +47,9 @@
         <a:solidFill>
           <a:schemeClr val="tx1"/>
         </a:solidFill>
-        <a:latin typeface="+mn-lt"/>
-        <a:ea typeface="+mn-ea"/>
-        <a:cs typeface="+mn-cs"/>
+        <a:latin typeface="Arial"/>
+        <a:ea typeface="Arial"/>
+        <a:cs typeface="Arial"/>
       </a:defRPr>
     </a:lvl3pPr>
     <a:lvl4pPr marL="1371600" algn="l" defTabSz="914400" rtl="0" eaLnBrk="1" latinLnBrk="0" hangingPunct="1">
@@ -66,9 +57,9 @@
         <a:solidFill>
           <a:schemeClr val="tx1"/>
         </a:solidFill>
-        <a:latin typeface="+mn-lt"/>
-        <a:ea typeface="+mn-ea"/>
-        <a:cs typeface="+mn-cs"/>
+        <a:latin typeface="Arial"/>
+        <a:ea typeface="Arial"/>
+        <a:cs typeface="Arial"/>
       </a:defRPr>
     </a:lvl4pPr>
     <a:lvl5pPr marL="1828800" algn="l" defTabSz="914400" rtl="0" eaLnBrk="1" latinLnBrk="0" hangingPunct="1">
@@ -76,9 +67,9 @@
         <a:solidFill>
           <a:schemeClr val="tx1"/>
         </a:solidFill>
-        <a:latin typeface="+mn-lt"/>
-        <a:ea typeface="+mn-ea"/>
-        <a:cs typeface="+mn-cs"/>
+        <a:latin typeface="Arial"/>
+        <a:ea typeface="Arial"/>
+        <a:cs typeface="Arial"/>
       </a:defRPr>
     </a:lvl5pPr>
     <a:lvl6pPr marL="2286000" algn="l" defTabSz="914400" rtl="0" eaLnBrk="1" latinLnBrk="0" hangingPunct="1">
@@ -86,9 +77,9 @@
         <a:solidFill>
           <a:schemeClr val="tx1"/>
         </a:solidFill>
-        <a:latin typeface="+mn-lt"/>
-        <a:ea typeface="+mn-ea"/>
-        <a:cs typeface="+mn-cs"/>
+        <a:latin typeface="Arial"/>
+        <a:ea typeface="Arial"/>
+        <a:cs typeface="Arial"/>
       </a:defRPr>
     </a:lvl6pPr>
     <a:lvl7pPr marL="2743200" algn="l" defTabSz="914400" rtl="0" eaLnBrk="1" latinLnBrk="0" hangingPunct="1">
@@ -96,9 +87,9 @@
         <a:solidFill>
           <a:schemeClr val="tx1"/>
         </a:solidFill>
-        <a:latin typeface="+mn-lt"/>
-        <a:ea typeface="+mn-ea"/>
-        <a:cs typeface="+mn-cs"/>
+        <a:latin typeface="Arial"/>
+        <a:ea typeface="Arial"/>
+        <a:cs typeface="Arial"/>
       </a:defRPr>
     </a:lvl7pPr>
     <a:lvl8pPr marL="3200400" algn="l" defTabSz="914400" rtl="0" eaLnBrk="1" latinLnBrk="0" hangingPunct="1">
@@ -106,9 +97,9 @@
         <a:solidFill>
           <a:schemeClr val="tx1"/>
         </a:solidFill>
-        <a:latin typeface="+mn-lt"/>
-        <a:ea typeface="+mn-ea"/>
-        <a:cs typeface="+mn-cs"/>
+        <a:latin typeface="Arial"/>
+        <a:ea typeface="Arial"/>
+        <a:cs typeface="Arial"/>
       </a:defRPr>
     </a:lvl8pPr>
     <a:lvl9pPr marL="3657600" algn="l" defTabSz="914400" rtl="0" eaLnBrk="1" latinLnBrk="0" hangingPunct="1">
@@ -116,9 +107,9 @@
         <a:solidFill>
           <a:schemeClr val="tx1"/>
         </a:solidFill>
-        <a:latin typeface="+mn-lt"/>
-        <a:ea typeface="+mn-ea"/>
-        <a:cs typeface="+mn-cs"/>
+        <a:latin typeface="Arial"/>
+        <a:ea typeface="Arial"/>
+        <a:cs typeface="Arial"/>
       </a:defRPr>
     </a:lvl9pPr>
   </p:defaultTextStyle>
@@ -390,9 +381,9 @@
         <a:solidFill>
           <a:schemeClr val="tx1"/>
         </a:solidFill>
-        <a:latin typeface="+mn-lt"/>
-        <a:ea typeface="+mn-ea"/>
-        <a:cs typeface="+mn-cs"/>
+        <a:latin typeface="Arial"/>
+        <a:ea typeface="Arial"/>
+        <a:cs typeface="Arial"/>
       </a:defRPr>
     </a:lvl1pPr>
     <a:lvl2pPr marL="457200" algn="l" defTabSz="914400" rtl="0" eaLnBrk="1" latinLnBrk="0" hangingPunct="1">
@@ -400,9 +391,9 @@
         <a:solidFill>
           <a:schemeClr val="tx1"/>
         </a:solidFill>
-        <a:latin typeface="+mn-lt"/>
-        <a:ea typeface="+mn-ea"/>
-        <a:cs typeface="+mn-cs"/>
+        <a:latin typeface="Arial"/>
+        <a:ea typeface="Arial"/>
+        <a:cs typeface="Arial"/>
       </a:defRPr>
     </a:lvl2pPr>
     <a:lvl3pPr marL="914400" algn="l" defTabSz="914400" rtl="0" eaLnBrk="1" latinLnBrk="0" hangingPunct="1">
@@ -410,9 +401,9 @@
         <a:solidFill>
           <a:schemeClr val="tx1"/>
         </a:solidFill>
-        <a:latin typeface="+mn-lt"/>
-        <a:ea typeface="+mn-ea"/>
-        <a:cs typeface="+mn-cs"/>
+        <a:latin typeface="Arial"/>
+        <a:ea typeface="Arial"/>
+        <a:cs typeface="Arial"/>
       </a:defRPr>
     </a:lvl3pPr>
     <a:lvl4pPr marL="1371600" algn="l" defTabSz="914400" rtl="0" eaLnBrk="1" latinLnBrk="0" hangingPunct="1">
@@ -420,9 +411,9 @@
         <a:solidFill>
           <a:schemeClr val="tx1"/>
         </a:solidFill>
-        <a:latin typeface="+mn-lt"/>
-        <a:ea typeface="+mn-ea"/>
-        <a:cs typeface="+mn-cs"/>
+        <a:latin typeface="Arial"/>
+        <a:ea typeface="Arial"/>
+        <a:cs typeface="Arial"/>
       </a:defRPr>
     </a:lvl4pPr>
     <a:lvl5pPr marL="1828800" algn="l" defTabSz="914400" rtl="0" eaLnBrk="1" latinLnBrk="0" hangingPunct="1">
@@ -430,9 +421,9 @@
         <a:solidFill>
           <a:schemeClr val="tx1"/>
         </a:solidFill>
-        <a:latin typeface="+mn-lt"/>
-        <a:ea typeface="+mn-ea"/>
-        <a:cs typeface="+mn-cs"/>
+        <a:latin typeface="Arial"/>
+        <a:ea typeface="Arial"/>
+        <a:cs typeface="Arial"/>
       </a:defRPr>
     </a:lvl5pPr>
     <a:lvl6pPr marL="2286000" algn="l" defTabSz="914400" rtl="0" eaLnBrk="1" latinLnBrk="0" hangingPunct="1">
@@ -440,9 +431,9 @@
         <a:solidFill>
           <a:schemeClr val="tx1"/>
         </a:solidFill>
-        <a:latin typeface="+mn-lt"/>
-        <a:ea typeface="+mn-ea"/>
-        <a:cs typeface="+mn-cs"/>
+        <a:latin typeface="Arial"/>
+        <a:ea typeface="Arial"/>
+        <a:cs typeface="Arial"/>
       </a:defRPr>
     </a:lvl6pPr>
     <a:lvl7pPr marL="2743200" algn="l" defTabSz="914400" rtl="0" eaLnBrk="1" latinLnBrk="0" hangingPunct="1">
@@ -450,9 +441,9 @@
         <a:solidFill>
           <a:schemeClr val="tx1"/>
         </a:solidFill>
-        <a:latin typeface="+mn-lt"/>
-        <a:ea typeface="+mn-ea"/>
-        <a:cs typeface="+mn-cs"/>
+        <a:latin typeface="Arial"/>
+        <a:ea typeface="Arial"/>
+        <a:cs typeface="Arial"/>
       </a:defRPr>
     </a:lvl7pPr>
     <a:lvl8pPr marL="3200400" algn="l" defTabSz="914400" rtl="0" eaLnBrk="1" latinLnBrk="0" hangingPunct="1">
@@ -460,9 +451,9 @@
         <a:solidFill>
           <a:schemeClr val="tx1"/>
         </a:solidFill>
-        <a:latin typeface="+mn-lt"/>
-        <a:ea typeface="+mn-ea"/>
-        <a:cs typeface="+mn-cs"/>
+        <a:latin typeface="Arial"/>
+        <a:ea typeface="Arial"/>
+        <a:cs typeface="Arial"/>
       </a:defRPr>
     </a:lvl8pPr>
     <a:lvl9pPr marL="3657600" algn="l" defTabSz="914400" rtl="0" eaLnBrk="1" latinLnBrk="0" hangingPunct="1">
@@ -470,9 +461,9 @@
         <a:solidFill>
           <a:schemeClr val="tx1"/>
         </a:solidFill>
-        <a:latin typeface="+mn-lt"/>
-        <a:ea typeface="+mn-ea"/>
-        <a:cs typeface="+mn-cs"/>
+        <a:latin typeface="Arial"/>
+        <a:ea typeface="Arial"/>
+        <a:cs typeface="Arial"/>
       </a:defRPr>
     </a:lvl9pPr>
   </p:notesStyle>
@@ -774,9 +765,9 @@
                 <a:solidFill>
                   <a:schemeClr val="tx1"/>
                 </a:solidFill>
-                <a:latin typeface="+mn-lt"/>
-                <a:ea typeface="+mn-ea"/>
-                <a:cs typeface="+mn-cs"/>
+                <a:latin typeface="Arial"/>
+                <a:ea typeface="Arial"/>
+                <a:cs typeface="Arial"/>
               </a:defRPr>
             </a:lvl1pPr>
           </a:lstStyle>
@@ -999,9 +990,9 @@
                 <a:solidFill>
                   <a:schemeClr val="tx1"/>
                 </a:solidFill>
-                <a:latin typeface="+mn-lt"/>
-                <a:ea typeface="+mn-ea"/>
-                <a:cs typeface="+mn-cs"/>
+                <a:latin typeface="Arial"/>
+                <a:ea typeface="Arial"/>
+                <a:cs typeface="Arial"/>
               </a:defRPr>
             </a:lvl1pPr>
           </a:lstStyle>
@@ -1291,9 +1282,9 @@
                 <a:solidFill>
                   <a:schemeClr val="tx1"/>
                 </a:solidFill>
-                <a:latin typeface="+mn-lt"/>
-                <a:ea typeface="+mn-ea"/>
-                <a:cs typeface="+mn-cs"/>
+                <a:latin typeface="Arial"/>
+                <a:ea typeface="Arial"/>
+                <a:cs typeface="Arial"/>
               </a:defRPr>
             </a:lvl1pPr>
           </a:lstStyle>
@@ -1643,9 +1634,9 @@
                 <a:solidFill>
                   <a:schemeClr val="tx1"/>
                 </a:solidFill>
-                <a:latin typeface="+mn-lt"/>
-                <a:ea typeface="+mn-ea"/>
-                <a:cs typeface="+mn-cs"/>
+                <a:latin typeface="Arial"/>
+                <a:ea typeface="Arial"/>
+                <a:cs typeface="Arial"/>
               </a:defRPr>
             </a:lvl1pPr>
           </a:lstStyle>
@@ -1971,9 +1962,9 @@
                 <a:solidFill>
                   <a:schemeClr val="tx1"/>
                 </a:solidFill>
-                <a:latin typeface="+mn-lt"/>
-                <a:ea typeface="+mn-ea"/>
-                <a:cs typeface="+mn-cs"/>
+                <a:latin typeface="Arial"/>
+                <a:ea typeface="Arial"/>
+                <a:cs typeface="Arial"/>
               </a:defRPr>
             </a:lvl1pPr>
           </a:lstStyle>
@@ -2129,9 +2120,9 @@
                 <a:solidFill>
                   <a:schemeClr val="tx1"/>
                 </a:solidFill>
-                <a:latin typeface="+mn-lt"/>
-                <a:ea typeface="+mn-ea"/>
-                <a:cs typeface="+mn-cs"/>
+                <a:latin typeface="Arial"/>
+                <a:ea typeface="Arial"/>
+                <a:cs typeface="Arial"/>
               </a:defRPr>
             </a:lvl1pPr>
           </a:lstStyle>
@@ -2394,9 +2385,9 @@
                 <a:solidFill>
                   <a:schemeClr val="tx1"/>
                 </a:solidFill>
-                <a:latin typeface="+mn-lt"/>
-                <a:ea typeface="+mn-ea"/>
-                <a:cs typeface="+mn-cs"/>
+                <a:latin typeface="Arial"/>
+                <a:ea typeface="Arial"/>
+                <a:cs typeface="Arial"/>
               </a:defRPr>
             </a:lvl1pPr>
           </a:lstStyle>
@@ -2443,9 +2434,9 @@
           <a:solidFill>
             <a:schemeClr val="tx1"/>
           </a:solidFill>
-          <a:latin typeface="+mj-lt"/>
-          <a:ea typeface="+mj-ea"/>
-          <a:cs typeface="+mj-cs"/>
+          <a:latin typeface="Arial"/>
+          <a:ea typeface="Arial"/>
+          <a:cs typeface="Arial"/>
         </a:defRPr>
       </a:lvl1pPr>
     </p:titleStyle>
@@ -2457,15 +2448,15 @@
         <a:spcBef>
           <a:spcPts val="1000"/>
         </a:spcBef>
-        <a:buFont typeface="Arial" panose="020B0604020202020204" pitchFamily="34" charset="0"/>
+        <a:buFont typeface="Arial"/>
         <a:buChar char="•"/>
         <a:defRPr sz="2400" kern="1200">
           <a:solidFill>
             <a:schemeClr val="tx1"/>
           </a:solidFill>
-          <a:latin typeface="+mn-lt"/>
-          <a:ea typeface="+mn-ea"/>
-          <a:cs typeface="+mn-cs"/>
+          <a:latin typeface="Arial"/>
+          <a:ea typeface="Arial"/>
+          <a:cs typeface="Arial"/>
         </a:defRPr>
       </a:lvl1pPr>
       <a:lvl2pPr marL="685800" indent="-228600" algn="l" defTabSz="914400" rtl="0" eaLnBrk="1" latinLnBrk="0" hangingPunct="1">
@@ -2475,15 +2466,15 @@
         <a:spcBef>
           <a:spcPts val="500"/>
         </a:spcBef>
-        <a:buFont typeface="Arial" panose="020B0604020202020204" pitchFamily="34" charset="0"/>
+        <a:buFont typeface="Arial"/>
         <a:buChar char="•"/>
         <a:defRPr sz="2000" kern="1200">
           <a:solidFill>
             <a:schemeClr val="tx1"/>
           </a:solidFill>
-          <a:latin typeface="+mn-lt"/>
-          <a:ea typeface="+mn-ea"/>
-          <a:cs typeface="+mn-cs"/>
+          <a:latin typeface="Arial"/>
+          <a:ea typeface="Arial"/>
+          <a:cs typeface="Arial"/>
         </a:defRPr>
       </a:lvl2pPr>
       <a:lvl3pPr marL="1143000" indent="-228600" algn="l" defTabSz="914400" rtl="0" eaLnBrk="1" latinLnBrk="0" hangingPunct="1">
@@ -2493,15 +2484,15 @@
         <a:spcBef>
           <a:spcPts val="500"/>
         </a:spcBef>
-        <a:buFont typeface="Arial" panose="020B0604020202020204" pitchFamily="34" charset="0"/>
+        <a:buFont typeface="Arial"/>
         <a:buChar char="•"/>
         <a:defRPr sz="1800" kern="1200">
           <a:solidFill>
             <a:schemeClr val="tx1"/>
           </a:solidFill>
-          <a:latin typeface="+mn-lt"/>
-          <a:ea typeface="+mn-ea"/>
-          <a:cs typeface="+mn-cs"/>
+          <a:latin typeface="Arial"/>
+          <a:ea typeface="Arial"/>
+          <a:cs typeface="Arial"/>
         </a:defRPr>
       </a:lvl3pPr>
       <a:lvl4pPr marL="1600200" indent="-228600" algn="l" defTabSz="914400" rtl="0" eaLnBrk="1" latinLnBrk="0" hangingPunct="1">
@@ -2511,15 +2502,15 @@
         <a:spcBef>
           <a:spcPts val="500"/>
         </a:spcBef>
-        <a:buFont typeface="Arial" panose="020B0604020202020204" pitchFamily="34" charset="0"/>
+        <a:buFont typeface="Arial"/>
         <a:buChar char="•"/>
         <a:defRPr sz="1800" kern="1200">
           <a:solidFill>
             <a:schemeClr val="tx1"/>
           </a:solidFill>
-          <a:latin typeface="+mn-lt"/>
-          <a:ea typeface="+mn-ea"/>
-          <a:cs typeface="+mn-cs"/>
+          <a:latin typeface="Arial"/>
+          <a:ea typeface="Arial"/>
+          <a:cs typeface="Arial"/>
         </a:defRPr>
       </a:lvl4pPr>
       <a:lvl5pPr marL="2057400" indent="-228600" algn="l" defTabSz="914400" rtl="0" eaLnBrk="1" latinLnBrk="0" hangingPunct="1">
@@ -2529,15 +2520,15 @@
         <a:spcBef>
           <a:spcPts val="500"/>
         </a:spcBef>
-        <a:buFont typeface="Arial" panose="020B0604020202020204" pitchFamily="34" charset="0"/>
+        <a:buFont typeface="Arial"/>
         <a:buChar char="•"/>
         <a:defRPr sz="1800" kern="1200">
           <a:solidFill>
             <a:schemeClr val="tx1"/>
           </a:solidFill>
-          <a:latin typeface="+mn-lt"/>
-          <a:ea typeface="+mn-ea"/>
-          <a:cs typeface="+mn-cs"/>
+          <a:latin typeface="Arial"/>
+          <a:ea typeface="Arial"/>
+          <a:cs typeface="Arial"/>
         </a:defRPr>
       </a:lvl5pPr>
       <a:lvl6pPr marL="2514600" indent="-228600" algn="l" defTabSz="914400" rtl="0" eaLnBrk="1" latinLnBrk="0" hangingPunct="1">
@@ -2547,15 +2538,15 @@
         <a:spcBef>
           <a:spcPts val="500"/>
         </a:spcBef>
-        <a:buFont typeface="Arial" panose="020B0604020202020204" pitchFamily="34" charset="0"/>
+        <a:buFont typeface="Arial"/>
         <a:buChar char="•"/>
         <a:defRPr sz="1800" kern="1200">
           <a:solidFill>
             <a:schemeClr val="tx1"/>
           </a:solidFill>
-          <a:latin typeface="+mn-lt"/>
-          <a:ea typeface="+mn-ea"/>
-          <a:cs typeface="+mn-cs"/>
+          <a:latin typeface="Arial"/>
+          <a:ea typeface="Arial"/>
+          <a:cs typeface="Arial"/>
         </a:defRPr>
       </a:lvl6pPr>
       <a:lvl7pPr marL="2971800" indent="-228600" algn="l" defTabSz="914400" rtl="0" eaLnBrk="1" latinLnBrk="0" hangingPunct="1">
@@ -2565,15 +2556,15 @@
         <a:spcBef>
           <a:spcPts val="500"/>
         </a:spcBef>
-        <a:buFont typeface="Arial" panose="020B0604020202020204" pitchFamily="34" charset="0"/>
+        <a:buFont typeface="Arial"/>
         <a:buChar char="•"/>
         <a:defRPr sz="1800" kern="1200">
           <a:solidFill>
             <a:schemeClr val="tx1"/>
           </a:solidFill>
-          <a:latin typeface="+mn-lt"/>
-          <a:ea typeface="+mn-ea"/>
-          <a:cs typeface="+mn-cs"/>
+          <a:latin typeface="Arial"/>
+          <a:ea typeface="Arial"/>
+          <a:cs typeface="Arial"/>
         </a:defRPr>
       </a:lvl7pPr>
       <a:lvl8pPr marL="3429000" indent="-228600" algn="l" defTabSz="914400" rtl="0" eaLnBrk="1" latinLnBrk="0" hangingPunct="1">
@@ -2583,15 +2574,15 @@
         <a:spcBef>
           <a:spcPts val="500"/>
         </a:spcBef>
-        <a:buFont typeface="Arial" panose="020B0604020202020204" pitchFamily="34" charset="0"/>
+        <a:buFont typeface="Arial"/>
         <a:buChar char="•"/>
         <a:defRPr sz="1800" kern="1200">
           <a:solidFill>
             <a:schemeClr val="tx1"/>
           </a:solidFill>
-          <a:latin typeface="+mn-lt"/>
-          <a:ea typeface="+mn-ea"/>
-          <a:cs typeface="+mn-cs"/>
+          <a:latin typeface="Arial"/>
+          <a:ea typeface="Arial"/>
+          <a:cs typeface="Arial"/>
         </a:defRPr>
       </a:lvl8pPr>
       <a:lvl9pPr marL="3886200" indent="-228600" algn="l" defTabSz="914400" rtl="0" eaLnBrk="1" latinLnBrk="0" hangingPunct="1">
@@ -2601,15 +2592,15 @@
         <a:spcBef>
           <a:spcPts val="500"/>
         </a:spcBef>
-        <a:buFont typeface="Arial" panose="020B0604020202020204" pitchFamily="34" charset="0"/>
+        <a:buFont typeface="Arial"/>
         <a:buChar char="•"/>
         <a:defRPr sz="1800" kern="1200">
           <a:solidFill>
             <a:schemeClr val="tx1"/>
           </a:solidFill>
-          <a:latin typeface="+mn-lt"/>
-          <a:ea typeface="+mn-ea"/>
-          <a:cs typeface="+mn-cs"/>
+          <a:latin typeface="Arial"/>
+          <a:ea typeface="Arial"/>
+          <a:cs typeface="Arial"/>
         </a:defRPr>
       </a:lvl9pPr>
     </p:bodyStyle>
@@ -2622,9 +2613,9 @@
           <a:solidFill>
             <a:schemeClr val="tx1"/>
           </a:solidFill>
-          <a:latin typeface="+mn-lt"/>
-          <a:ea typeface="+mn-ea"/>
-          <a:cs typeface="+mn-cs"/>
+          <a:latin typeface="Arial"/>
+          <a:ea typeface="Arial"/>
+          <a:cs typeface="Arial"/>
         </a:defRPr>
       </a:lvl1pPr>
       <a:lvl2pPr marL="457200" algn="l" defTabSz="914400" rtl="0" eaLnBrk="1" latinLnBrk="0" hangingPunct="1">
@@ -2632,9 +2623,9 @@
           <a:solidFill>
             <a:schemeClr val="tx1"/>
           </a:solidFill>
-          <a:latin typeface="+mn-lt"/>
-          <a:ea typeface="+mn-ea"/>
-          <a:cs typeface="+mn-cs"/>
+          <a:latin typeface="Arial"/>
+          <a:ea typeface="Arial"/>
+          <a:cs typeface="Arial"/>
         </a:defRPr>
       </a:lvl2pPr>
       <a:lvl3pPr marL="914400" algn="l" defTabSz="914400" rtl="0" eaLnBrk="1" latinLnBrk="0" hangingPunct="1">
@@ -2642,9 +2633,9 @@
           <a:solidFill>
             <a:schemeClr val="tx1"/>
           </a:solidFill>
-          <a:latin typeface="+mn-lt"/>
-          <a:ea typeface="+mn-ea"/>
-          <a:cs typeface="+mn-cs"/>
+          <a:latin typeface="Arial"/>
+          <a:ea typeface="Arial"/>
+          <a:cs typeface="Arial"/>
         </a:defRPr>
       </a:lvl3pPr>
       <a:lvl4pPr marL="1371600" algn="l" defTabSz="914400" rtl="0" eaLnBrk="1" latinLnBrk="0" hangingPunct="1">
@@ -2652,9 +2643,9 @@
           <a:solidFill>
             <a:schemeClr val="tx1"/>
           </a:solidFill>
-          <a:latin typeface="+mn-lt"/>
-          <a:ea typeface="+mn-ea"/>
-          <a:cs typeface="+mn-cs"/>
+          <a:latin typeface="Arial"/>
+          <a:ea typeface="Arial"/>
+          <a:cs typeface="Arial"/>
         </a:defRPr>
       </a:lvl4pPr>
       <a:lvl5pPr marL="1828800" algn="l" defTabSz="914400" rtl="0" eaLnBrk="1" latinLnBrk="0" hangingPunct="1">
@@ -2662,9 +2653,9 @@
           <a:solidFill>
             <a:schemeClr val="tx1"/>
           </a:solidFill>
-          <a:latin typeface="+mn-lt"/>
-          <a:ea typeface="+mn-ea"/>
-          <a:cs typeface="+mn-cs"/>
+          <a:latin typeface="Arial"/>
+          <a:ea typeface="Arial"/>
+          <a:cs typeface="Arial"/>
         </a:defRPr>
       </a:lvl5pPr>
       <a:lvl6pPr marL="2286000" algn="l" defTabSz="914400" rtl="0" eaLnBrk="1" latinLnBrk="0" hangingPunct="1">
@@ -2672,9 +2663,9 @@
           <a:solidFill>
             <a:schemeClr val="tx1"/>
           </a:solidFill>
-          <a:latin typeface="+mn-lt"/>
-          <a:ea typeface="+mn-ea"/>
-          <a:cs typeface="+mn-cs"/>
+          <a:latin typeface="Arial"/>
+          <a:ea typeface="Arial"/>
+          <a:cs typeface="Arial"/>
         </a:defRPr>
       </a:lvl6pPr>
       <a:lvl7pPr marL="2743200" algn="l" defTabSz="914400" rtl="0" eaLnBrk="1" latinLnBrk="0" hangingPunct="1">
@@ -2682,9 +2673,9 @@
           <a:solidFill>
             <a:schemeClr val="tx1"/>
           </a:solidFill>
-          <a:latin typeface="+mn-lt"/>
-          <a:ea typeface="+mn-ea"/>
-          <a:cs typeface="+mn-cs"/>
+          <a:latin typeface="Arial"/>
+          <a:ea typeface="Arial"/>
+          <a:cs typeface="Arial"/>
         </a:defRPr>
       </a:lvl7pPr>
       <a:lvl8pPr marL="3200400" algn="l" defTabSz="914400" rtl="0" eaLnBrk="1" latinLnBrk="0" hangingPunct="1">
@@ -2692,9 +2683,9 @@
           <a:solidFill>
             <a:schemeClr val="tx1"/>
           </a:solidFill>
-          <a:latin typeface="+mn-lt"/>
-          <a:ea typeface="+mn-ea"/>
-          <a:cs typeface="+mn-cs"/>
+          <a:latin typeface="Arial"/>
+          <a:ea typeface="Arial"/>
+          <a:cs typeface="Arial"/>
         </a:defRPr>
       </a:lvl8pPr>
       <a:lvl9pPr marL="3657600" algn="l" defTabSz="914400" rtl="0" eaLnBrk="1" latinLnBrk="0" hangingPunct="1">
@@ -2702,9 +2693,9 @@
           <a:solidFill>
             <a:schemeClr val="tx1"/>
           </a:solidFill>
-          <a:latin typeface="+mn-lt"/>
-          <a:ea typeface="+mn-ea"/>
-          <a:cs typeface="+mn-cs"/>
+          <a:latin typeface="Arial"/>
+          <a:ea typeface="Arial"/>
+          <a:cs typeface="Arial"/>
         </a:defRPr>
       </a:lvl9pPr>
     </p:otherStyle>
@@ -2930,7 +2921,7 @@
                 <a:solidFill>
                   <a:srgbClr val="00B8D7"/>
                 </a:solidFill>
-                <a:latin typeface="Aptos"/>
+                <a:latin typeface="Arial"/>
               </a:rPr>
               <a:t>OCP HACKATHON 2026</a:t>
             </a:r>
@@ -2967,7 +2958,7 @@
                 <a:solidFill>
                   <a:srgbClr val="08172F"/>
                 </a:solidFill>
-                <a:latin typeface="Aptos"/>
+                <a:latin typeface="Arial"/>
               </a:rPr>
               <a:t>PersonaForge</a:t>
             </a:r>
@@ -3004,7 +2995,7 @@
                 <a:solidFill>
                   <a:srgbClr val="34383D"/>
                 </a:solidFill>
-                <a:latin typeface="Aptos"/>
+                <a:latin typeface="Arial"/>
               </a:rPr>
               <a:t>Purpose-built SONiC.</a:t>
             </a:r>
@@ -3017,7 +3008,7 @@
                 <a:solidFill>
                   <a:srgbClr val="687985"/>
                 </a:solidFill>
-                <a:latin typeface="Aptos"/>
+                <a:latin typeface="Arial"/>
               </a:rPr>
               <a:t>One persona. Build lean. Adapt at runtime.</a:t>
             </a:r>
@@ -3056,7 +3047,7 @@
                 <a:solidFill>
                   <a:srgbClr val="08172F"/>
                 </a:solidFill>
-                <a:latin typeface="Aptos"/>
+                <a:latin typeface="Arial"/>
               </a:rPr>
               <a:t>CATEGORY: Developer experience improvements: builds, CI/CD</a:t>
             </a:r>
@@ -3088,6 +3079,7 @@
         <p:txBody>
           <a:bodyPr wrap="square" lIns="0" rIns="0" tIns="0" bIns="0" anchor="t"/>
           <a:lstStyle/>
+          <a:p/>
         </p:txBody>
       </p:sp>
       <p:sp>
@@ -3119,7 +3111,7 @@
                 <a:solidFill>
                   <a:srgbClr val="009B77"/>
                 </a:solidFill>
-                <a:latin typeface="Aptos"/>
+                <a:latin typeface="Arial"/>
               </a:rPr>
               <a:t>TEAM • Dell Technologies</a:t>
             </a:r>
@@ -3156,7 +3148,7 @@
                 <a:solidFill>
                   <a:srgbClr val="34383D"/>
                 </a:solidFill>
-                <a:latin typeface="Aptos"/>
+                <a:latin typeface="Arial"/>
               </a:rPr>
               <a:t>Rathnasabapathy Velautharaj</a:t>
             </a:r>
@@ -3169,7 +3161,7 @@
                 <a:solidFill>
                   <a:srgbClr val="687985"/>
                 </a:solidFill>
-                <a:latin typeface="Aptos"/>
+                <a:latin typeface="Arial"/>
               </a:rPr>
               <a:t>Rathna.Sabapathy@dell.com</a:t>
             </a:r>
@@ -3206,7 +3198,7 @@
                 <a:solidFill>
                   <a:srgbClr val="34383D"/>
                 </a:solidFill>
-                <a:latin typeface="Aptos"/>
+                <a:latin typeface="Arial"/>
               </a:rPr>
               <a:t>Phaniraj Vattem</a:t>
             </a:r>
@@ -3219,7 +3211,7 @@
                 <a:solidFill>
                   <a:srgbClr val="687985"/>
                 </a:solidFill>
-                <a:latin typeface="Aptos"/>
+                <a:latin typeface="Arial"/>
               </a:rPr>
               <a:t>Phaniraj.Vattem@dell.com</a:t>
             </a:r>
@@ -3256,7 +3248,7 @@
                 <a:solidFill>
                   <a:srgbClr val="34383D"/>
                 </a:solidFill>
-                <a:latin typeface="Aptos"/>
+                <a:latin typeface="Arial"/>
               </a:rPr>
               <a:t>Maheshwara Hampasagar</a:t>
             </a:r>
@@ -3269,7 +3261,7 @@
                 <a:solidFill>
                   <a:srgbClr val="687985"/>
                 </a:solidFill>
-                <a:latin typeface="Aptos"/>
+                <a:latin typeface="Arial"/>
               </a:rPr>
               <a:t>Maheshwara.Hampasaga@dell.com</a:t>
             </a:r>
@@ -3306,7 +3298,7 @@
                 <a:solidFill>
                   <a:srgbClr val="34383D"/>
                 </a:solidFill>
-                <a:latin typeface="Aptos"/>
+                <a:latin typeface="Arial"/>
               </a:rPr>
               <a:t>Tejaswi Goel</a:t>
             </a:r>
@@ -3319,7 +3311,7 @@
                 <a:solidFill>
                   <a:srgbClr val="687985"/>
                 </a:solidFill>
-                <a:latin typeface="Aptos"/>
+                <a:latin typeface="Arial"/>
               </a:rPr>
               <a:t>Tejaswi.Goel@Dell.com</a:t>
             </a:r>
@@ -3356,7 +3348,7 @@
                 <a:solidFill>
                   <a:srgbClr val="34383D"/>
                 </a:solidFill>
-                <a:latin typeface="Aptos"/>
+                <a:latin typeface="Arial"/>
               </a:rPr>
               <a:t>Sucheta Mahara</a:t>
             </a:r>
@@ -3369,7 +3361,7 @@
                 <a:solidFill>
                   <a:srgbClr val="687985"/>
                 </a:solidFill>
-                <a:latin typeface="Aptos"/>
+                <a:latin typeface="Arial"/>
               </a:rPr>
               <a:t>Sucheta.Mahara@dell.com</a:t>
             </a:r>
@@ -3457,7 +3449,7 @@
                 <a:solidFill>
                   <a:srgbClr val="00B8D7"/>
                 </a:solidFill>
-                <a:latin typeface="Aptos"/>
+                <a:latin typeface="Arial"/>
               </a:rPr>
               <a:t>PRIOR WORK + HACKATHON CONTRIBUTION</a:t>
             </a:r>
@@ -3494,7 +3486,7 @@
                 <a:solidFill>
                   <a:srgbClr val="FFFFFF"/>
                 </a:solidFill>
-                <a:latin typeface="Aptos"/>
+                <a:latin typeface="Arial"/>
               </a:rPr>
               <a:t>Existing SONiC controls. New persona workflow.</a:t>
             </a:r>
@@ -3531,7 +3523,7 @@
                 <a:solidFill>
                   <a:srgbClr val="FFFFFF"/>
                 </a:solidFill>
-                <a:latin typeface="Aptos"/>
+                <a:latin typeface="Arial"/>
               </a:rPr>
               <a:t>02</a:t>
             </a:r>
@@ -3572,7 +3564,7 @@
                 <a:solidFill>
                   <a:srgbClr val="687985"/>
                 </a:solidFill>
-                <a:latin typeface="Aptos"/>
+                <a:latin typeface="Arial"/>
               </a:rPr>
               <a:t>BEFORE THE HACKATHON</a:t>
             </a:r>
@@ -3585,7 +3577,7 @@
                 <a:solidFill>
                   <a:srgbClr val="34383D"/>
                 </a:solidFill>
-                <a:latin typeface="Aptos"/>
+                <a:latin typeface="Arial"/>
               </a:rPr>
               <a:t>Existing SONiC foundations</a:t>
             </a:r>
@@ -3598,7 +3590,7 @@
                 <a:solidFill>
                   <a:srgbClr val="34383D"/>
                 </a:solidFill>
-                <a:latin typeface="Aptos"/>
+                <a:latin typeface="Arial"/>
               </a:rPr>
               <a:t>FEATURE: service lifecycle</a:t>
             </a:r>
@@ -3611,7 +3603,7 @@
                 <a:solidFill>
                   <a:srgbClr val="34383D"/>
                 </a:solidFill>
-                <a:latin typeface="Aptos"/>
+                <a:latin typeface="Arial"/>
               </a:rPr>
               <a:t>Make / INCLUDE_*: image selection</a:t>
             </a:r>
@@ -3624,7 +3616,7 @@
                 <a:solidFill>
                   <a:srgbClr val="34383D"/>
                 </a:solidFill>
-                <a:latin typeface="Aptos"/>
+                <a:latin typeface="Arial"/>
               </a:rPr>
               <a:t>ConfigDB + config save: persistence</a:t>
             </a:r>
@@ -3637,7 +3629,7 @@
                 <a:solidFill>
                   <a:srgbClr val="34383D"/>
                 </a:solidFill>
-                <a:latin typeface="Aptos"/>
+                <a:latin typeface="Arial"/>
               </a:rPr>
               <a:t>FRR startup + supervisor: daemons</a:t>
             </a:r>
@@ -3678,7 +3670,7 @@
                 <a:solidFill>
                   <a:srgbClr val="009B77"/>
                 </a:solidFill>
-                <a:latin typeface="Aptos"/>
+                <a:latin typeface="Arial"/>
               </a:rPr>
               <a:t>BUILT DURING THE HACKATHON</a:t>
             </a:r>
@@ -3691,7 +3683,7 @@
                 <a:solidFill>
                   <a:srgbClr val="34383D"/>
                 </a:solidFill>
-                <a:latin typeface="Aptos"/>
+                <a:latin typeface="Arial"/>
               </a:rPr>
               <a:t>PersonaForge integration</a:t>
             </a:r>
@@ -3704,7 +3696,7 @@
                 <a:solidFill>
                   <a:srgbClr val="34383D"/>
                 </a:solidFill>
-                <a:latin typeface="Aptos"/>
+                <a:latin typeface="Arial"/>
               </a:rPr>
               <a:t>Reusable schema for YAML personas</a:t>
             </a:r>
@@ -3717,7 +3709,7 @@
                 <a:solidFill>
                   <a:srgbClr val="009B77"/>
                 </a:solidFill>
-                <a:latin typeface="Aptos"/>
+                <a:latin typeface="Arial"/>
               </a:rPr>
               <a:t>PERSONAFORGE_PROFILE build option</a:t>
             </a:r>
@@ -3730,7 +3722,7 @@
                 <a:solidFill>
                   <a:srgbClr val="34383D"/>
                 </a:solidFill>
-                <a:latin typeface="Aptos"/>
+                <a:latin typeface="Arial"/>
               </a:rPr>
               <a:t>Native plan / apply / status / drift</a:t>
             </a:r>
@@ -3743,7 +3735,7 @@
                 <a:solidFill>
                   <a:srgbClr val="34383D"/>
                 </a:solidFill>
-                <a:latin typeface="Aptos"/>
+                <a:latin typeface="Arial"/>
               </a:rPr>
               <a:t>Persistent FEATURE + FRR daemon policy</a:t>
             </a:r>
@@ -3756,7 +3748,7 @@
                 <a:solidFill>
                   <a:srgbClr val="34383D"/>
                 </a:solidFill>
-                <a:latin typeface="Aptos"/>
+                <a:latin typeface="Arial"/>
               </a:rPr>
               <a:t>Automated tests + three-DUT evidence</a:t>
             </a:r>
@@ -3795,7 +3787,7 @@
                 <a:solidFill>
                   <a:srgbClr val="08172F"/>
                 </a:solidFill>
-                <a:latin typeface="Aptos"/>
+                <a:latin typeface="Arial"/>
               </a:rPr>
               <a:t>Our contribution: one reusable role across build and runtime.</a:t>
             </a:r>
@@ -3883,7 +3875,7 @@
                 <a:solidFill>
                   <a:srgbClr val="00B8D7"/>
                 </a:solidFill>
-                <a:latin typeface="Aptos"/>
+                <a:latin typeface="Arial"/>
               </a:rPr>
               <a:t>THE JUDGE'S QUESTION</a:t>
             </a:r>
@@ -3920,7 +3912,7 @@
                 <a:solidFill>
                   <a:srgbClr val="FFFFFF"/>
                 </a:solidFill>
-                <a:latin typeface="Aptos"/>
+                <a:latin typeface="Arial"/>
               </a:rPr>
               <a:t>If FEATURE can stop it, why PersonaForge?</a:t>
             </a:r>
@@ -3957,7 +3949,7 @@
                 <a:solidFill>
                   <a:srgbClr val="FFFFFF"/>
                 </a:solidFill>
-                <a:latin typeface="Aptos"/>
+                <a:latin typeface="Arial"/>
               </a:rPr>
               <a:t>03</a:t>
             </a:r>
@@ -3998,7 +3990,7 @@
                 <a:solidFill>
                   <a:srgbClr val="687985"/>
                 </a:solidFill>
-                <a:latin typeface="Aptos"/>
+                <a:latin typeface="Arial"/>
               </a:rPr>
               <a:t>FULL IMAGE</a:t>
             </a:r>
@@ -4011,7 +4003,7 @@
                 <a:solidFill>
                   <a:srgbClr val="34383D"/>
                 </a:solidFill>
-                <a:latin typeface="Aptos"/>
+                <a:latin typeface="Arial"/>
               </a:rPr>
               <a:t>13 running</a:t>
             </a:r>
@@ -4024,7 +4016,7 @@
                 <a:solidFill>
                   <a:srgbClr val="34383D"/>
                 </a:solidFill>
-                <a:latin typeface="Aptos"/>
+                <a:latin typeface="Arial"/>
               </a:rPr>
               <a:t>28 Docker repos</a:t>
             </a:r>
@@ -4037,7 +4029,7 @@
                 <a:solidFill>
                   <a:srgbClr val="687985"/>
                 </a:solidFill>
-                <a:latin typeface="Aptos"/>
+                <a:latin typeface="Arial"/>
               </a:rPr>
               <a:t>Broad capability ships</a:t>
             </a:r>
@@ -4050,7 +4042,7 @@
                 <a:solidFill>
                   <a:srgbClr val="687985"/>
                 </a:solidFill>
-                <a:latin typeface="Aptos"/>
+                <a:latin typeface="Arial"/>
               </a:rPr>
               <a:t>Optional services remain available</a:t>
             </a:r>
@@ -4091,7 +4083,7 @@
                 <a:solidFill>
                   <a:srgbClr val="00B8D7"/>
                 </a:solidFill>
-                <a:latin typeface="Aptos"/>
+                <a:latin typeface="Arial"/>
               </a:rPr>
               <a:t>FEATURE-DISABLED</a:t>
             </a:r>
@@ -4104,7 +4096,7 @@
                 <a:solidFill>
                   <a:srgbClr val="00B8D7"/>
                 </a:solidFill>
-                <a:latin typeface="Aptos"/>
+                <a:latin typeface="Arial"/>
               </a:rPr>
               <a:t>9 running</a:t>
             </a:r>
@@ -4117,7 +4109,7 @@
                 <a:solidFill>
                   <a:srgbClr val="34383D"/>
                 </a:solidFill>
-                <a:latin typeface="Aptos"/>
+                <a:latin typeface="Arial"/>
               </a:rPr>
               <a:t>28 Docker repos</a:t>
             </a:r>
@@ -4130,7 +4122,7 @@
                 <a:solidFill>
                   <a:srgbClr val="687985"/>
                 </a:solidFill>
-                <a:latin typeface="Aptos"/>
+                <a:latin typeface="Arial"/>
               </a:rPr>
               <a:t>Active footprint drops</a:t>
             </a:r>
@@ -4143,7 +4135,7 @@
                 <a:solidFill>
                   <a:srgbClr val="D44848"/>
                 </a:solidFill>
-                <a:latin typeface="Aptos"/>
+                <a:latin typeface="Arial"/>
               </a:rPr>
               <a:t>Installed payload does not</a:t>
             </a:r>
@@ -4184,7 +4176,7 @@
                 <a:solidFill>
                   <a:srgbClr val="009B77"/>
                 </a:solidFill>
-                <a:latin typeface="Aptos"/>
+                <a:latin typeface="Arial"/>
               </a:rPr>
               <a:t>BUILD PERSONA</a:t>
             </a:r>
@@ -4197,7 +4189,7 @@
                 <a:solidFill>
                   <a:srgbClr val="687985"/>
                 </a:solidFill>
-                <a:latin typeface="Aptos"/>
+                <a:latin typeface="Arial"/>
               </a:rPr>
               <a:t>Sample persona</a:t>
             </a:r>
@@ -4210,7 +4202,7 @@
                 <a:solidFill>
                   <a:srgbClr val="08172F"/>
                 </a:solidFill>
-                <a:latin typeface="Aptos"/>
+                <a:latin typeface="Arial"/>
               </a:rPr>
               <a:t>l3-bgp-leaf-no-lag</a:t>
             </a:r>
@@ -4223,7 +4215,7 @@
                 <a:solidFill>
                   <a:srgbClr val="009B77"/>
                 </a:solidFill>
-                <a:latin typeface="Aptos"/>
+                <a:latin typeface="Arial"/>
               </a:rPr>
               <a:t>9 running</a:t>
             </a:r>
@@ -4236,7 +4228,7 @@
                 <a:solidFill>
                   <a:srgbClr val="34383D"/>
                 </a:solidFill>
-                <a:latin typeface="Aptos"/>
+                <a:latin typeface="Arial"/>
               </a:rPr>
               <a:t>19 Docker repos</a:t>
             </a:r>
@@ -4249,7 +4241,7 @@
                 <a:solidFill>
                   <a:srgbClr val="687985"/>
                 </a:solidFill>
-                <a:latin typeface="Aptos"/>
+                <a:latin typeface="Arial"/>
               </a:rPr>
               <a:t>Retains BGP + core services</a:t>
             </a:r>
@@ -4262,7 +4254,7 @@
                 <a:solidFill>
                   <a:srgbClr val="009B77"/>
                 </a:solidFill>
-                <a:latin typeface="Aptos"/>
+                <a:latin typeface="Arial"/>
               </a:rPr>
               <a:t>9 repositories physically absent</a:t>
             </a:r>
@@ -4275,7 +4267,7 @@
                 <a:solidFill>
                   <a:srgbClr val="34383D"/>
                 </a:solidFill>
-                <a:latin typeface="Aptos"/>
+                <a:latin typeface="Arial"/>
               </a:rPr>
               <a:t>Less dormant software to secure</a:t>
             </a:r>
@@ -4288,7 +4280,7 @@
                 <a:solidFill>
                   <a:srgbClr val="687985"/>
                 </a:solidFill>
-                <a:latin typeface="Aptos"/>
+                <a:latin typeface="Arial"/>
               </a:rPr>
               <a:t>This sample omits service images:</a:t>
             </a:r>
@@ -4301,7 +4293,7 @@
                 <a:solidFill>
                   <a:srgbClr val="34383D"/>
                 </a:solidFill>
-                <a:latin typeface="Aptos"/>
+                <a:latin typeface="Arial"/>
               </a:rPr>
               <a:t>gNMI • LLDP • SNMP • TEAMD</a:t>
             </a:r>
@@ -4340,7 +4332,7 @@
                 <a:solidFill>
                   <a:srgbClr val="08172F"/>
                 </a:solidFill>
-                <a:latin typeface="Aptos"/>
+                <a:latin typeface="Arial"/>
               </a:rPr>
               <a:t>Runtime controls activity.  Build controls shipment.  One persona defines both.</a:t>
             </a:r>
@@ -4428,7 +4420,7 @@
                 <a:solidFill>
                   <a:srgbClr val="00B8D7"/>
                 </a:solidFill>
-                <a:latin typeface="Aptos"/>
+                <a:latin typeface="Arial"/>
               </a:rPr>
               <a:t>THE INNOVATION</a:t>
             </a:r>
@@ -4465,7 +4457,7 @@
                 <a:solidFill>
                   <a:srgbClr val="FFFFFF"/>
                 </a:solidFill>
-                <a:latin typeface="Aptos"/>
+                <a:latin typeface="Arial"/>
               </a:rPr>
               <a:t>One persona compiles into two operating models</a:t>
             </a:r>
@@ -4502,7 +4494,7 @@
                 <a:solidFill>
                   <a:srgbClr val="FFFFFF"/>
                 </a:solidFill>
-                <a:latin typeface="Aptos"/>
+                <a:latin typeface="Arial"/>
               </a:rPr>
               <a:t>04</a:t>
             </a:r>
@@ -4543,7 +4535,7 @@
                 <a:solidFill>
                   <a:srgbClr val="00B8D7"/>
                 </a:solidFill>
-                <a:latin typeface="Aptos"/>
+                <a:latin typeface="Arial"/>
               </a:rPr>
               <a:t>DECLARE ONCE</a:t>
             </a:r>
@@ -4556,7 +4548,7 @@
                 <a:solidFill>
                   <a:srgbClr val="34383D"/>
                 </a:solidFill>
-                <a:latin typeface="Aptos"/>
+                <a:latin typeface="Arial"/>
               </a:rPr>
               <a:t>Persona YAML</a:t>
             </a:r>
@@ -4569,7 +4561,7 @@
                 <a:solidFill>
                   <a:srgbClr val="687985"/>
                 </a:solidFill>
-                <a:latin typeface="Aptos"/>
+                <a:latin typeface="Arial"/>
               </a:rPr>
               <a:t>required / omit  •  feature state  •  FRR daemon policy  •  persistence intent</a:t>
             </a:r>
@@ -4606,7 +4598,7 @@
                 <a:solidFill>
                   <a:srgbClr val="009B77"/>
                 </a:solidFill>
-                <a:latin typeface="Aptos"/>
+                <a:latin typeface="Arial"/>
               </a:rPr>
               <a:t>↓</a:t>
             </a:r>
@@ -4643,7 +4635,7 @@
                 <a:solidFill>
                   <a:srgbClr val="198FD3"/>
                 </a:solidFill>
-                <a:latin typeface="Aptos"/>
+                <a:latin typeface="Arial"/>
               </a:rPr>
               <a:t>↓</a:t>
             </a:r>
@@ -4660,7 +4652,7 @@
         <p:spPr>
           <a:xfrm>
             <a:off x="603504" y="2834640"/>
-            <a:ext cx="5074920" cy="2450592"/>
+            <a:ext cx="5074920" cy="2651760"/>
           </a:xfrm>
           <a:prstGeom prst="roundRect">
             <a:avLst/>
@@ -4684,7 +4676,7 @@
                 <a:solidFill>
                   <a:srgbClr val="009B77"/>
                 </a:solidFill>
-                <a:latin typeface="Aptos"/>
+                <a:latin typeface="Arial"/>
               </a:rPr>
               <a:t>BUILD PATH • NEW PROFILE OPTION</a:t>
             </a:r>
@@ -4697,7 +4689,7 @@
                 <a:solidFill>
                   <a:srgbClr val="34383D"/>
                 </a:solidFill>
-                <a:latin typeface="Aptos"/>
+                <a:latin typeface="Arial"/>
               </a:rPr>
               <a:t>Normal SONiC Make</a:t>
             </a:r>
@@ -4710,7 +4702,7 @@
                 <a:solidFill>
                   <a:srgbClr val="009B77"/>
                 </a:solidFill>
-                <a:latin typeface="Aptos"/>
+                <a:latin typeface="Arial"/>
               </a:rPr>
               <a:t>make PERSONAFORGE_PROFILE=l3-bgp-leaf-no-lag \</a:t>
             </a:r>
@@ -4723,7 +4715,7 @@
                 <a:solidFill>
                   <a:srgbClr val="009B77"/>
                 </a:solidFill>
-                <a:latin typeface="Aptos"/>
+                <a:latin typeface="Arial"/>
               </a:rPr>
               <a:t>    target/sonic-broadcom.bin</a:t>
             </a:r>
@@ -4736,7 +4728,7 @@
                 <a:solidFill>
                   <a:srgbClr val="34383D"/>
                 </a:solidFill>
-                <a:latin typeface="Aptos"/>
+                <a:latin typeface="Arial"/>
               </a:rPr>
               <a:t>Profile selects composition; target stays standard</a:t>
             </a:r>
@@ -4749,7 +4741,7 @@
                 <a:solidFill>
                   <a:srgbClr val="687985"/>
                 </a:solidFill>
-                <a:latin typeface="Aptos"/>
+                <a:latin typeface="Arial"/>
               </a:rPr>
               <a:t>No profile selected: normal SONiC build</a:t>
             </a:r>
@@ -4766,7 +4758,7 @@
         <p:spPr>
           <a:xfrm>
             <a:off x="6190488" y="2834640"/>
-            <a:ext cx="5093208" cy="2450592"/>
+            <a:ext cx="5093208" cy="2651760"/>
           </a:xfrm>
           <a:prstGeom prst="roundRect">
             <a:avLst/>
@@ -4783,6 +4775,7 @@
         <p:txBody>
           <a:bodyPr wrap="square" lIns="0" rIns="0" tIns="0" bIns="0" anchor="t"/>
           <a:lstStyle/>
+          <a:p/>
         </p:txBody>
       </p:sp>
       <p:sp>
@@ -4814,7 +4807,7 @@
                 <a:solidFill>
                   <a:srgbClr val="198FD3"/>
                 </a:solidFill>
-                <a:latin typeface="Aptos"/>
+                <a:latin typeface="Arial"/>
               </a:rPr>
               <a:t>RUNTIME PATH • IMPLEMENTED</a:t>
             </a:r>
@@ -4851,7 +4844,7 @@
                 <a:solidFill>
                   <a:srgbClr val="34383D"/>
                 </a:solidFill>
-                <a:latin typeface="Aptos"/>
+                <a:latin typeface="Arial"/>
               </a:rPr>
               <a:t>Native SONiC CLI</a:t>
             </a:r>
@@ -4867,8 +4860,8 @@
         </p:nvSpPr>
         <p:spPr>
           <a:xfrm>
-            <a:off x="6437376" y="3703320"/>
-            <a:ext cx="4599432" cy="1143000"/>
+            <a:off x="6437376" y="3712463"/>
+            <a:ext cx="4599432" cy="1344168"/>
           </a:xfrm>
           <a:prstGeom prst="rect">
             <a:avLst/>
@@ -4888,76 +4881,76 @@
                 <a:solidFill>
                   <a:srgbClr val="687985"/>
                 </a:solidFill>
-                <a:latin typeface="Consolas"/>
-              </a:rPr>
-              <a:t>PF_PROFILE=l3-bgp-leaf-no-lag</a:t>
+                <a:latin typeface="Arial"/>
+              </a:rPr>
+              <a:t>COMMAND OVERVIEW</a:t>
             </a:r>
             <a:endParaRPr lang="en-US" sz="1000"/>
           </a:p>
           <a:p>
             <a:pPr algn="l"/>
             <a:r>
-              <a:rPr lang="en-US" sz="1100" dirty="0">
+              <a:rPr lang="en-US" sz="1400" dirty="0">
                 <a:solidFill>
                   <a:srgbClr val="08172F"/>
                 </a:solidFill>
-                <a:latin typeface="Consolas"/>
-              </a:rPr>
-              <a:t>show personaforge plan "$PF_PROFILE"</a:t>
-            </a:r>
-            <a:endParaRPr lang="en-US" sz="1100"/>
-          </a:p>
-          <a:p>
-            <a:pPr algn="l"/>
-            <a:r>
-              <a:rPr lang="en-US" sz="1100" dirty="0" b="1">
+                <a:latin typeface="Arial"/>
+              </a:rPr>
+              <a:t>show personaforge plan &lt;profile&gt;</a:t>
+            </a:r>
+            <a:endParaRPr lang="en-US" sz="1400"/>
+          </a:p>
+          <a:p>
+            <a:pPr algn="l"/>
+            <a:r>
+              <a:rPr lang="en-US" sz="1400" dirty="0" b="1">
                 <a:solidFill>
                   <a:srgbClr val="198FD3"/>
                 </a:solidFill>
-                <a:latin typeface="Consolas"/>
-              </a:rPr>
-              <a:t>sudo config personaforge apply "$PF_PROFILE" \</a:t>
-            </a:r>
-            <a:endParaRPr lang="en-US" sz="1100"/>
-          </a:p>
-          <a:p>
-            <a:pPr algn="l"/>
-            <a:r>
-              <a:rPr lang="en-US" sz="1100" dirty="0">
+                <a:latin typeface="Arial"/>
+              </a:rPr>
+              <a:t>config personaforge apply &lt;profile&gt;</a:t>
+            </a:r>
+            <a:endParaRPr lang="en-US" sz="1400"/>
+          </a:p>
+          <a:p>
+            <a:pPr algn="l"/>
+            <a:r>
+              <a:rPr lang="en-US" sz="1400" dirty="0">
+                <a:solidFill>
+                  <a:srgbClr val="08172F"/>
+                </a:solidFill>
+                <a:latin typeface="Arial"/>
+              </a:rPr>
+              <a:t>show personaforge status</a:t>
+            </a:r>
+            <a:endParaRPr lang="en-US" sz="1400"/>
+          </a:p>
+          <a:p>
+            <a:pPr algn="l"/>
+            <a:r>
+              <a:rPr lang="en-US" sz="1400" dirty="0">
+                <a:solidFill>
+                  <a:srgbClr val="08172F"/>
+                </a:solidFill>
+                <a:latin typeface="Arial"/>
+              </a:rPr>
+              <a:t>show personaforge drift</a:t>
+            </a:r>
+            <a:endParaRPr lang="en-US" sz="1400"/>
+          </a:p>
+          <a:p>
+            <a:pPr algn="l"/>
+            <a:r>
+              <a:rPr lang="en-US" sz="1400" dirty="0" b="1">
                 <a:solidFill>
                   <a:srgbClr val="198FD3"/>
                 </a:solidFill>
-                <a:latin typeface="Consolas"/>
-              </a:rPr>
-              <a:t>  --persist --allow-disruptive -y</a:t>
-            </a:r>
-            <a:endParaRPr lang="en-US" sz="1100"/>
-          </a:p>
-          <a:p>
-            <a:pPr algn="l"/>
-            <a:r>
-              <a:rPr lang="en-US" sz="1100" dirty="0">
-                <a:solidFill>
-                  <a:srgbClr val="08172F"/>
-                </a:solidFill>
-                <a:latin typeface="Consolas"/>
-              </a:rPr>
-              <a:t>show personaforge status --detail</a:t>
-            </a:r>
-            <a:endParaRPr lang="en-US" sz="1100"/>
-          </a:p>
-          <a:p>
-            <a:pPr algn="l"/>
-            <a:r>
-              <a:rPr lang="en-US" sz="1100" dirty="0">
-                <a:solidFill>
-                  <a:srgbClr val="08172F"/>
-                </a:solidFill>
-                <a:latin typeface="Consolas"/>
-              </a:rPr>
-              <a:t>show personaforge drift</a:t>
-            </a:r>
-            <a:endParaRPr lang="en-US" sz="1100"/>
+                <a:latin typeface="Arial"/>
+              </a:rPr>
+              <a:t>config personaforge deactivate</a:t>
+            </a:r>
+            <a:endParaRPr lang="en-US" sz="1400"/>
           </a:p>
         </p:txBody>
       </p:sp>
@@ -4969,8 +4962,8 @@
         </p:nvSpPr>
         <p:spPr>
           <a:xfrm>
-            <a:off x="6437376" y="4983480"/>
-            <a:ext cx="4590288" cy="210312"/>
+            <a:off x="6437376" y="5175504"/>
+            <a:ext cx="4590288" cy="228600"/>
           </a:xfrm>
           <a:prstGeom prst="rect">
             <a:avLst/>
@@ -4990,9 +4983,9 @@
                 <a:solidFill>
                   <a:srgbClr val="009B77"/>
                 </a:solidFill>
-                <a:latin typeface="Aptos"/>
-              </a:rPr>
-              <a:t>Persists across node + container restarts</a:t>
+                <a:latin typeface="Arial"/>
+              </a:rPr>
+              <a:t>Apply a role. Restore captured settings.</a:t>
             </a:r>
             <a:endParaRPr lang="en-US" sz="1200"/>
           </a:p>
@@ -5006,7 +4999,7 @@
         </p:nvSpPr>
         <p:spPr>
           <a:xfrm>
-            <a:off x="603504" y="5477256"/>
+            <a:off x="603504" y="5623560"/>
             <a:ext cx="10680192" cy="713232"/>
           </a:xfrm>
           <a:prstGeom prst="roundRect">
@@ -5029,7 +5022,7 @@
                 <a:solidFill>
                   <a:srgbClr val="08172F"/>
                 </a:solidFill>
-                <a:latin typeface="Aptos"/>
+                <a:latin typeface="Arial"/>
               </a:rPr>
               <a:t>Safety: schema + conflict checks • protected core • explicit disruption authorization</a:t>
             </a:r>
@@ -5042,7 +5035,7 @@
                 <a:solidFill>
                   <a:srgbClr val="198FD3"/>
                 </a:solidFill>
-                <a:latin typeface="Aptos"/>
+                <a:latin typeface="Arial"/>
               </a:rPr>
               <a:t>Add personas through YAML • reusable, platform-independent contract</a:t>
             </a:r>
@@ -5130,7 +5123,7 @@
                 <a:solidFill>
                   <a:srgbClr val="00B8D7"/>
                 </a:solidFill>
-                <a:latin typeface="Aptos"/>
+                <a:latin typeface="Arial"/>
               </a:rPr>
               <a:t>MEASURED FOOTPRINT + SECURITY VALUE</a:t>
             </a:r>
@@ -5167,7 +5160,7 @@
                 <a:solidFill>
                   <a:srgbClr val="FFFFFF"/>
                 </a:solidFill>
-                <a:latin typeface="Aptos"/>
+                <a:latin typeface="Arial"/>
               </a:rPr>
               <a:t>Smaller footprint. Less software exposure.</a:t>
             </a:r>
@@ -5204,7 +5197,7 @@
                 <a:solidFill>
                   <a:srgbClr val="FFFFFF"/>
                 </a:solidFill>
-                <a:latin typeface="Aptos"/>
+                <a:latin typeface="Arial"/>
               </a:rPr>
               <a:t>05</a:t>
             </a:r>
@@ -5245,7 +5238,7 @@
                 <a:solidFill>
                   <a:srgbClr val="009B77"/>
                 </a:solidFill>
-                <a:latin typeface="Aptos"/>
+                <a:latin typeface="Arial"/>
               </a:rPr>
               <a:t>7.1%</a:t>
             </a:r>
@@ -5258,7 +5251,7 @@
                 <a:solidFill>
                   <a:srgbClr val="34383D"/>
                 </a:solidFill>
-                <a:latin typeface="Aptos"/>
+                <a:latin typeface="Arial"/>
               </a:rPr>
               <a:t>smaller installer</a:t>
             </a:r>
@@ -5271,7 +5264,7 @@
                 <a:solidFill>
                   <a:srgbClr val="687985"/>
                 </a:solidFill>
-                <a:latin typeface="Aptos"/>
+                <a:latin typeface="Arial"/>
               </a:rPr>
               <a:t>80.9 MB removed</a:t>
             </a:r>
@@ -5312,7 +5305,7 @@
                 <a:solidFill>
                   <a:srgbClr val="009B77"/>
                 </a:solidFill>
-                <a:latin typeface="Aptos"/>
+                <a:latin typeface="Arial"/>
               </a:rPr>
               <a:t>10.0%</a:t>
             </a:r>
@@ -5325,7 +5318,7 @@
                 <a:solidFill>
                   <a:srgbClr val="34383D"/>
                 </a:solidFill>
-                <a:latin typeface="Aptos"/>
+                <a:latin typeface="Arial"/>
               </a:rPr>
               <a:t>smaller installed</a:t>
             </a:r>
@@ -5338,7 +5331,7 @@
                 <a:solidFill>
                   <a:srgbClr val="687985"/>
                 </a:solidFill>
-                <a:latin typeface="Aptos"/>
+                <a:latin typeface="Arial"/>
               </a:rPr>
               <a:t>283.3 MB removed</a:t>
             </a:r>
@@ -5379,7 +5372,7 @@
                 <a:solidFill>
                   <a:srgbClr val="009B77"/>
                 </a:solidFill>
-                <a:latin typeface="Aptos"/>
+                <a:latin typeface="Arial"/>
               </a:rPr>
               <a:t>32.1%</a:t>
             </a:r>
@@ -5392,7 +5385,7 @@
                 <a:solidFill>
                   <a:srgbClr val="34383D"/>
                 </a:solidFill>
-                <a:latin typeface="Aptos"/>
+                <a:latin typeface="Arial"/>
               </a:rPr>
               <a:t>fewer Docker repos</a:t>
             </a:r>
@@ -5405,7 +5398,7 @@
                 <a:solidFill>
                   <a:srgbClr val="687985"/>
                 </a:solidFill>
-                <a:latin typeface="Aptos"/>
+                <a:latin typeface="Arial"/>
               </a:rPr>
               <a:t>28 → 19</a:t>
             </a:r>
@@ -5446,7 +5439,7 @@
                 <a:solidFill>
                   <a:srgbClr val="009B77"/>
                 </a:solidFill>
-                <a:latin typeface="Aptos"/>
+                <a:latin typeface="Arial"/>
               </a:rPr>
               <a:t>17.6%</a:t>
             </a:r>
@@ -5459,7 +5452,7 @@
                 <a:solidFill>
                   <a:srgbClr val="34383D"/>
                 </a:solidFill>
-                <a:latin typeface="Aptos"/>
+                <a:latin typeface="Arial"/>
               </a:rPr>
               <a:t>fewer Docker files</a:t>
             </a:r>
@@ -5472,7 +5465,7 @@
                 <a:solidFill>
                   <a:srgbClr val="687985"/>
                 </a:solidFill>
-                <a:latin typeface="Aptos"/>
+                <a:latin typeface="Arial"/>
               </a:rPr>
               <a:t>29,579 → 24,361</a:t>
             </a:r>
@@ -5511,7 +5504,7 @@
                 <a:solidFill>
                   <a:srgbClr val="009B77"/>
                 </a:solidFill>
-                <a:latin typeface="Aptos"/>
+                <a:latin typeface="Arial"/>
               </a:rPr>
               <a:t>SECURITY THROUGH LEAST FUNCTIONALITY</a:t>
             </a:r>
@@ -5524,7 +5517,7 @@
                 <a:solidFill>
                   <a:srgbClr val="34383D"/>
                 </a:solidFill>
-                <a:latin typeface="Aptos"/>
+                <a:latin typeface="Arial"/>
               </a:rPr>
               <a:t>Fewer components. Less potential exposure.</a:t>
             </a:r>
@@ -5537,7 +5530,7 @@
                 <a:solidFill>
                   <a:srgbClr val="009B77"/>
                 </a:solidFill>
-                <a:latin typeface="Aptos"/>
+                <a:latin typeface="Arial"/>
               </a:rPr>
               <a:t>9 repositories absent: less software to scan and maintain</a:t>
             </a:r>
@@ -5550,7 +5543,7 @@
                 <a:solidFill>
                   <a:srgbClr val="687985"/>
                 </a:solidFill>
-                <a:latin typeface="Aptos"/>
+                <a:latin typeface="Arial"/>
               </a:rPr>
               <a:t>Omitted containers require reinstallation to run</a:t>
             </a:r>
@@ -5563,7 +5556,7 @@
                 <a:solidFill>
                   <a:srgbClr val="687985"/>
                 </a:solidFill>
-                <a:latin typeface="Aptos"/>
+                <a:latin typeface="Arial"/>
               </a:rPr>
               <a:t>Repository reduction measured; CVE reduction not yet measured</a:t>
             </a:r>
@@ -5604,7 +5597,7 @@
                 <a:solidFill>
                   <a:srgbClr val="FFFFFF"/>
                 </a:solidFill>
-                <a:latin typeface="Aptos"/>
+                <a:latin typeface="Arial"/>
               </a:rPr>
               <a:t/>
             </a:r>
@@ -5641,7 +5634,7 @@
                 <a:solidFill>
                   <a:srgbClr val="00B8D7"/>
                 </a:solidFill>
-                <a:latin typeface="Aptos"/>
+                <a:latin typeface="Arial"/>
               </a:rPr>
               <a:t>RUNNING vs INSTALLED</a:t>
             </a:r>
@@ -5678,7 +5671,7 @@
                 <a:solidFill>
                   <a:srgbClr val="687985"/>
                 </a:solidFill>
-                <a:latin typeface="Aptos"/>
+                <a:latin typeface="Arial"/>
               </a:rPr>
               <a:t>FULL</a:t>
             </a:r>
@@ -5715,7 +5708,7 @@
                 <a:solidFill>
                   <a:srgbClr val="198FD3"/>
                 </a:solidFill>
-                <a:latin typeface="Aptos"/>
+                <a:latin typeface="Arial"/>
               </a:rPr>
               <a:t>FEATURE</a:t>
             </a:r>
@@ -5728,7 +5721,7 @@
                 <a:solidFill>
                   <a:srgbClr val="198FD3"/>
                 </a:solidFill>
-                <a:latin typeface="Aptos"/>
+                <a:latin typeface="Arial"/>
               </a:rPr>
               <a:t>DISABLED</a:t>
             </a:r>
@@ -5765,7 +5758,7 @@
                 <a:solidFill>
                   <a:srgbClr val="009B77"/>
                 </a:solidFill>
-                <a:latin typeface="Aptos"/>
+                <a:latin typeface="Arial"/>
               </a:rPr>
               <a:t>BUILD</a:t>
             </a:r>
@@ -5802,7 +5795,7 @@
                 <a:solidFill>
                   <a:srgbClr val="34383D"/>
                 </a:solidFill>
-                <a:latin typeface="Aptos"/>
+                <a:latin typeface="Arial"/>
               </a:rPr>
               <a:t>Running</a:t>
             </a:r>
@@ -5815,7 +5808,7 @@
                 <a:solidFill>
                   <a:srgbClr val="687985"/>
                 </a:solidFill>
-                <a:latin typeface="Aptos"/>
+                <a:latin typeface="Arial"/>
               </a:rPr>
               <a:t>containers</a:t>
             </a:r>
@@ -5852,7 +5845,7 @@
                 <a:solidFill>
                   <a:srgbClr val="34383D"/>
                 </a:solidFill>
-                <a:latin typeface="Aptos"/>
+                <a:latin typeface="Arial"/>
               </a:rPr>
               <a:t>Installed</a:t>
             </a:r>
@@ -5865,7 +5858,7 @@
                 <a:solidFill>
                   <a:srgbClr val="687985"/>
                 </a:solidFill>
-                <a:latin typeface="Aptos"/>
+                <a:latin typeface="Arial"/>
               </a:rPr>
               <a:t>Docker repos</a:t>
             </a:r>
@@ -5902,7 +5895,7 @@
                 <a:solidFill>
                   <a:srgbClr val="34383D"/>
                 </a:solidFill>
-                <a:latin typeface="Aptos"/>
+                <a:latin typeface="Arial"/>
               </a:rPr>
               <a:t>13</a:t>
             </a:r>
@@ -5939,7 +5932,7 @@
                 <a:solidFill>
                   <a:srgbClr val="198FD3"/>
                 </a:solidFill>
-                <a:latin typeface="Aptos"/>
+                <a:latin typeface="Arial"/>
               </a:rPr>
               <a:t>9</a:t>
             </a:r>
@@ -5976,7 +5969,7 @@
                 <a:solidFill>
                   <a:srgbClr val="009B77"/>
                 </a:solidFill>
-                <a:latin typeface="Aptos"/>
+                <a:latin typeface="Arial"/>
               </a:rPr>
               <a:t>9</a:t>
             </a:r>
@@ -6013,7 +6006,7 @@
                 <a:solidFill>
                   <a:srgbClr val="34383D"/>
                 </a:solidFill>
-                <a:latin typeface="Aptos"/>
+                <a:latin typeface="Arial"/>
               </a:rPr>
               <a:t>28</a:t>
             </a:r>
@@ -6050,7 +6043,7 @@
                 <a:solidFill>
                   <a:srgbClr val="198FD3"/>
                 </a:solidFill>
-                <a:latin typeface="Aptos"/>
+                <a:latin typeface="Arial"/>
               </a:rPr>
               <a:t>28</a:t>
             </a:r>
@@ -6087,7 +6080,7 @@
                 <a:solidFill>
                   <a:srgbClr val="009B77"/>
                 </a:solidFill>
-                <a:latin typeface="Aptos"/>
+                <a:latin typeface="Arial"/>
               </a:rPr>
               <a:t>19</a:t>
             </a:r>
@@ -6126,7 +6119,7 @@
                 <a:solidFill>
                   <a:srgbClr val="08172F"/>
                 </a:solidFill>
-                <a:latin typeface="Aptos"/>
+                <a:latin typeface="Arial"/>
               </a:rPr>
               <a:t>13 → 9: FOUR SERVICES</a:t>
             </a:r>
@@ -6139,7 +6132,7 @@
                 <a:solidFill>
                   <a:srgbClr val="198FD3"/>
                 </a:solidFill>
-                <a:latin typeface="Aptos"/>
+                <a:latin typeface="Arial"/>
               </a:rPr>
               <a:t>gnmi • lldp • snmp • teamd</a:t>
             </a:r>
@@ -6176,7 +6169,7 @@
                 <a:solidFill>
                   <a:srgbClr val="198FD3"/>
                 </a:solidFill>
-                <a:latin typeface="Aptos"/>
+                <a:latin typeface="Arial"/>
               </a:rPr>
               <a:t>FEATURE: services stopped</a:t>
             </a:r>
@@ -6189,7 +6182,7 @@
                 <a:solidFill>
                   <a:srgbClr val="009B77"/>
                 </a:solidFill>
-                <a:latin typeface="Aptos"/>
+                <a:latin typeface="Arial"/>
               </a:rPr>
               <a:t>BUILD: their images + 5 dormant repos omitted</a:t>
             </a:r>
@@ -6228,7 +6221,7 @@
                 <a:solidFill>
                   <a:srgbClr val="08172F"/>
                 </a:solidFill>
-                <a:latin typeface="Aptos"/>
+                <a:latin typeface="Arial"/>
               </a:rPr>
               <a:t>SCALE PRESERVED  •  64 VRFs  •  4,096 routes  •  completion spread &lt;1%</a:t>
             </a:r>
@@ -6241,7 +6234,7 @@
                 <a:solidFill>
                   <a:srgbClr val="687985"/>
                 </a:solidFill>
-                <a:latin typeface="Aptos"/>
+                <a:latin typeface="Arial"/>
               </a:rPr>
               <a:t>Broadcom three-DUT study • all healthy after cleanup</a:t>
             </a:r>
@@ -6254,7 +6247,7 @@
                 <a:solidFill>
                   <a:srgbClr val="687985"/>
                 </a:solidFill>
-                <a:latin typeface="Aptos"/>
+                <a:latin typeface="Arial"/>
               </a:rPr>
               <a:t>Separate BFDD lifecycle validation • 50 automated product tests</a:t>
             </a:r>
@@ -6342,9 +6335,9 @@
                 <a:solidFill>
                   <a:srgbClr val="00B8D7"/>
                 </a:solidFill>
-                <a:latin typeface="Aptos"/>
-              </a:rPr>
-              <a:t>RECORDED DEMO</a:t>
+                <a:latin typeface="Arial"/>
+              </a:rPr>
+              <a:t>CLICK VIDEO TO PLAY  •  BUILD + RUNTIME  •  1:46</a:t>
             </a:r>
             <a:endParaRPr lang="en-US" sz="900"/>
           </a:p>
@@ -6379,7 +6372,7 @@
                 <a:solidFill>
                   <a:srgbClr val="FFFFFF"/>
                 </a:solidFill>
-                <a:latin typeface="Aptos"/>
+                <a:latin typeface="Arial"/>
               </a:rPr>
               <a:t>PersonaForge in action</a:t>
             </a:r>
@@ -6416,7 +6409,7 @@
                 <a:solidFill>
                   <a:srgbClr val="FFFFFF"/>
                 </a:solidFill>
-                <a:latin typeface="Aptos"/>
+                <a:latin typeface="Arial"/>
               </a:rPr>
               <a:t>06</a:t>
             </a:r>
@@ -6424,78 +6417,66 @@
           </a:p>
         </p:txBody>
       </p:sp>
-      <p:sp>
-        <p:nvSpPr>
-          <p:cNvPr id="10" name="Text 10"/>
-          <p:cNvSpPr txBox="1"/>
-          <p:nvPr/>
-        </p:nvSpPr>
-        <p:spPr>
-          <a:xfrm>
-            <a:off x="1709928" y="1344168"/>
-            <a:ext cx="8778240" cy="4937760"/>
-          </a:xfrm>
-          <a:prstGeom prst="rect">
-            <a:avLst/>
-          </a:prstGeom>
-          <a:solidFill>
-            <a:srgbClr val="091A28"/>
-          </a:solidFill>
-          <a:ln w="12700">
-            <a:solidFill>
-              <a:srgbClr val="00B8D7"/>
-            </a:solidFill>
-          </a:ln>
-        </p:spPr>
-        <p:txBody>
-          <a:bodyPr wrap="square" lIns="182880" rIns="182880" tIns="182880" bIns="182880" anchor="ctr"/>
-          <a:lstStyle/>
-          <a:p>
-            <a:pPr algn="ctr"/>
-            <a:r>
-              <a:rPr lang="en-US" sz="2800" dirty="0" b="1">
-                <a:solidFill>
-                  <a:srgbClr val="FFFFFF"/>
-                </a:solidFill>
-                <a:latin typeface="Aptos"/>
-              </a:rPr>
-              <a:t>Demo video</a:t>
-            </a:r>
-            <a:endParaRPr lang="en-US" sz="2800"/>
-          </a:p>
-          <a:p>
-            <a:pPr algn="ctr"/>
-            <a:r>
-              <a:rPr lang="en-US" sz="1600" dirty="0" b="1">
-                <a:solidFill>
-                  <a:srgbClr val="00B8D7"/>
-                </a:solidFill>
-                <a:latin typeface="Aptos"/>
-              </a:rPr>
-              <a:t>2 minutes 30 seconds</a:t>
-            </a:r>
-            <a:endParaRPr lang="en-US" sz="1600"/>
-          </a:p>
-          <a:p>
-            <a:pPr algn="ctr"/>
-            <a:r>
-              <a:rPr lang="en-US" sz="1100" dirty="0">
-                <a:solidFill>
-                  <a:srgbClr val="A8BBC7"/>
-                </a:solidFill>
-                <a:latin typeface="Aptos"/>
-              </a:rPr>
-              <a:t>Recording to be inserted</a:t>
-            </a:r>
-            <a:endParaRPr lang="en-US" sz="1100"/>
-          </a:p>
-        </p:txBody>
-      </p:sp>
+      <p:pic>
+        <p:nvPicPr>
+          <p:cNvPr id="100" name="PersonaForge Build + Runtime Demo — 1:46 — Click to play" descr="Silent 1 minute 46 second demo: build persona, then runtime persona.">
+            <a:hlinkClick r:id="" action="ppaction://media"/>
+          </p:cNvPr>
+          <p:cNvPicPr>
+            <a:picLocks noChangeAspect="1"/>
+          </p:cNvPicPr>
+          <p:nvPr>
+            <a:videoFile r:link="rId4"/>
+            <p:extLst>
+              <p:ext uri="{DAA4B4D4-6D71-4841-9C94-3DE7FCFB9230}">
+                <p14:media xmlns:p14="http://schemas.microsoft.com/office/powerpoint/2010/main" r:embed="rId3"/>
+              </p:ext>
+            </p:extLst>
+          </p:nvPr>
+        </p:nvPicPr>
+        <p:blipFill>
+          <a:blip r:embed="rId5"/>
+          <a:stretch>
+            <a:fillRect/>
+          </a:stretch>
+        </p:blipFill>
+        <p:spPr>
+          <a:xfrm>
+            <a:off x="975360" y="1005840"/>
+            <a:ext cx="10241280" cy="5760720"/>
+          </a:xfrm>
+          <a:prstGeom prst="rect">
+            <a:avLst/>
+          </a:prstGeom>
+        </p:spPr>
+      </p:pic>
     </p:spTree>
   </p:cSld>
   <p:clrMapOvr>
     <a:masterClrMapping/>
   </p:clrMapOvr>
+  <p:timing>
+    <p:tnLst>
+      <p:par>
+        <p:cTn id="1" dur="indefinite" restart="never" nodeType="tmRoot">
+          <p:childTnLst>
+            <p:video>
+              <p:cMediaNode vol="80000">
+                <p:cTn id="2" fill="hold" display="0">
+                  <p:stCondLst>
+                    <p:cond delay="indefinite"/>
+                  </p:stCondLst>
+                </p:cTn>
+                <p:tgtEl>
+                  <p:spTgt spid="100"/>
+                </p:tgtEl>
+              </p:cMediaNode>
+            </p:video>
+          </p:childTnLst>
+        </p:cTn>
+      </p:par>
+    </p:tnLst>
+  </p:timing>
 </p:sld>
 </file>
 
@@ -6571,7 +6552,7 @@
                 <a:solidFill>
                   <a:srgbClr val="00B8D7"/>
                 </a:solidFill>
-                <a:latin typeface="Aptos"/>
+                <a:latin typeface="Arial"/>
               </a:rPr>
               <a:t>SOURCE + HACKATHON STATUS</a:t>
             </a:r>
@@ -6608,7 +6589,7 @@
                 <a:solidFill>
                   <a:srgbClr val="FFFFFF"/>
                 </a:solidFill>
-                <a:latin typeface="Aptos"/>
+                <a:latin typeface="Arial"/>
               </a:rPr>
               <a:t>Hackathon scope delivered. Real-device results.</a:t>
             </a:r>
@@ -6645,7 +6626,7 @@
                 <a:solidFill>
                   <a:srgbClr val="FFFFFF"/>
                 </a:solidFill>
-                <a:latin typeface="Aptos"/>
+                <a:latin typeface="Arial"/>
               </a:rPr>
               <a:t>07</a:t>
             </a:r>
@@ -6682,7 +6663,7 @@
                 <a:solidFill>
                   <a:srgbClr val="08172F"/>
                 </a:solidFill>
-                <a:latin typeface="Aptos"/>
+                <a:latin typeface="Arial"/>
               </a:rPr>
               <a:t>One persona. Build lean. Adapt at runtime.</a:t>
             </a:r>
@@ -6723,7 +6704,7 @@
                 <a:solidFill>
                   <a:srgbClr val="009B77"/>
                 </a:solidFill>
-                <a:latin typeface="Aptos"/>
+                <a:latin typeface="Arial"/>
               </a:rPr>
               <a:t>COMPLETED — HACKATHON</a:t>
             </a:r>
@@ -6736,7 +6717,7 @@
                 <a:solidFill>
                   <a:srgbClr val="34383D"/>
                 </a:solidFill>
-                <a:latin typeface="Aptos"/>
+                <a:latin typeface="Arial"/>
               </a:rPr>
               <a:t>Build + runtime personas</a:t>
             </a:r>
@@ -6749,7 +6730,7 @@
                 <a:solidFill>
                   <a:srgbClr val="34383D"/>
                 </a:solidFill>
-                <a:latin typeface="Aptos"/>
+                <a:latin typeface="Arial"/>
               </a:rPr>
               <a:t>l3-bgp-leaf-no-lag — lean BGP, no LAG</a:t>
             </a:r>
@@ -6762,7 +6743,7 @@
                 <a:solidFill>
                   <a:srgbClr val="34383D"/>
                 </a:solidFill>
-                <a:latin typeface="Aptos"/>
+                <a:latin typeface="Arial"/>
               </a:rPr>
               <a:t>l3-bgp-bfd-leaf — BGP + BFD detection</a:t>
             </a:r>
@@ -6775,7 +6756,7 @@
                 <a:solidFill>
                   <a:srgbClr val="34383D"/>
                 </a:solidFill>
-                <a:latin typeface="Aptos"/>
+                <a:latin typeface="Arial"/>
               </a:rPr>
               <a:t>l3-bgp-observability — BGP + monitoring</a:t>
             </a:r>
@@ -6788,24 +6769,11 @@
                 <a:solidFill>
                   <a:srgbClr val="34383D"/>
                 </a:solidFill>
-                <a:latin typeface="Aptos"/>
-              </a:rPr>
-              <a:t>l3-multirouting-lab — OSPF/PIM/PCEP daemons</a:t>
+                <a:latin typeface="Arial"/>
+              </a:rPr>
+              <a:t>l3-multirouting-lab — optional routing-daemon controls</a:t>
             </a:r>
             <a:endParaRPr lang="en-US" sz="1200"/>
-          </a:p>
-          <a:p>
-            <a:pPr algn="l"/>
-            <a:r>
-              <a:rPr lang="en-US" sz="1100" dirty="0" b="1">
-                <a:solidFill>
-                  <a:srgbClr val="009B77"/>
-                </a:solidFill>
-                <a:latin typeface="Aptos"/>
-              </a:rPr>
-              <a:t>Native CLI • persistence • FRR policy • scale study</a:t>
-            </a:r>
-            <a:endParaRPr lang="en-US" sz="1100"/>
           </a:p>
         </p:txBody>
       </p:sp>
@@ -6842,9 +6810,9 @@
                 <a:solidFill>
                   <a:srgbClr val="198FD3"/>
                 </a:solidFill>
-                <a:latin typeface="Aptos"/>
-              </a:rPr>
-              <a:t>PLANNED ENHANCEMENTS</a:t>
+                <a:latin typeface="Arial"/>
+              </a:rPr>
+              <a:t>DELIVERED IN SONiC</a:t>
             </a:r>
             <a:endParaRPr lang="en-US" sz="1200"/>
           </a:p>
@@ -6855,9 +6823,9 @@
                 <a:solidFill>
                   <a:srgbClr val="34383D"/>
                 </a:solidFill>
-                <a:latin typeface="Aptos"/>
-              </a:rPr>
-              <a:t>Recovery + automated qualification</a:t>
+                <a:latin typeface="Arial"/>
+              </a:rPr>
+              <a:t>One YAML. Two operating models.</a:t>
             </a:r>
             <a:endParaRPr lang="en-US" sz="1700"/>
           </a:p>
@@ -6868,37 +6836,37 @@
                 <a:solidFill>
                   <a:srgbClr val="34383D"/>
                 </a:solidFill>
-                <a:latin typeface="Aptos"/>
-              </a:rPr>
-              <a:t>Rollback • deeper dependency / health probes</a:t>
+                <a:latin typeface="Arial"/>
+              </a:rPr>
+              <a:t>Native CLI • persistence • manual rollback</a:t>
             </a:r>
             <a:endParaRPr lang="en-US" sz="1300"/>
           </a:p>
           <a:p>
             <a:pPr algn="l"/>
             <a:r>
-              <a:rPr lang="en-US" sz="1400" dirty="0">
+              <a:rPr lang="en-US" sz="1300" dirty="0">
                 <a:solidFill>
                   <a:srgbClr val="34383D"/>
                 </a:solidFill>
-                <a:latin typeface="Aptos"/>
-              </a:rPr>
-              <a:t>Artifact verification + integrated reporting</a:t>
-            </a:r>
-            <a:endParaRPr lang="en-US" sz="1400"/>
-          </a:p>
-          <a:p>
-            <a:pPr algn="l"/>
-            <a:r>
-              <a:rPr lang="en-US" sz="1400" dirty="0">
+                <a:latin typeface="Arial"/>
+              </a:rPr>
+              <a:t>Platform-independent persona contract</a:t>
+            </a:r>
+            <a:endParaRPr lang="en-US" sz="1300"/>
+          </a:p>
+          <a:p>
+            <a:pPr algn="l"/>
+            <a:r>
+              <a:rPr lang="en-US" sz="1300" dirty="0">
                 <a:solidFill>
                   <a:srgbClr val="34383D"/>
                 </a:solidFill>
-                <a:latin typeface="Aptos"/>
-              </a:rPr>
-              <a:t>More platforms + measured CVE assessment</a:t>
-            </a:r>
-            <a:endParaRPr lang="en-US" sz="1400"/>
+                <a:latin typeface="Arial"/>
+              </a:rPr>
+              <a:t>Real-device footprint + scale study</a:t>
+            </a:r>
+            <a:endParaRPr lang="en-US" sz="1300"/>
           </a:p>
         </p:txBody>
       </p:sp>
@@ -6933,7 +6901,7 @@
                 <a:solidFill>
                   <a:srgbClr val="009B77"/>
                 </a:solidFill>
-                <a:latin typeface="Aptos"/>
+                <a:latin typeface="Arial"/>
               </a:rPr>
               <a:t>STATUS: Completed</a:t>
             </a:r>
@@ -6946,7 +6914,7 @@
                 <a:solidFill>
                   <a:srgbClr val="687985"/>
                 </a:solidFill>
-                <a:latin typeface="Aptos"/>
+                <a:latin typeface="Arial"/>
               </a:rPr>
               <a:t>Hackathon scope: build + runtime implemented and demonstrated</a:t>
             </a:r>
@@ -6983,7 +6951,7 @@
                 <a:solidFill>
                   <a:srgbClr val="687985"/>
                 </a:solidFill>
-                <a:latin typeface="Aptos"/>
+                <a:latin typeface="Arial"/>
                 <a:hlinkClick r:id="rId3"/>
               </a:rPr>
               <a:t>BUILD + RUNTIME CORE</a:t>
@@ -6997,7 +6965,7 @@
                 <a:solidFill>
                   <a:srgbClr val="198FD3"/>
                 </a:solidFill>
-                <a:latin typeface="Aptos"/>
+                <a:latin typeface="Arial"/>
                 <a:hlinkClick r:id="rId3"/>
               </a:rPr>
               <a:t>github.com/mh-csonic/sonic-buildimage</a:t>
@@ -7035,7 +7003,7 @@
                 <a:solidFill>
                   <a:srgbClr val="687985"/>
                 </a:solidFill>
-                <a:latin typeface="Aptos"/>
+                <a:latin typeface="Arial"/>
                 <a:hlinkClick r:id="rId4"/>
               </a:rPr>
               <a:t>NATIVE SONiC CLI</a:t>
@@ -7049,7 +7017,7 @@
                 <a:solidFill>
                   <a:srgbClr val="198FD3"/>
                 </a:solidFill>
-                <a:latin typeface="Aptos"/>
+                <a:latin typeface="Arial"/>
                 <a:hlinkClick r:id="rId4"/>
               </a:rPr>
               <a:t>github.com/mh-csonic/sonic-utilities</a:t>
@@ -7087,7 +7055,7 @@
                 <a:solidFill>
                   <a:srgbClr val="687985"/>
                 </a:solidFill>
-                <a:latin typeface="Aptos"/>
+                <a:latin typeface="Arial"/>
               </a:rPr>
               <a:t>Source branch: rathnasabapathyv/2026_hackathon_persona</a:t>
             </a:r>
@@ -7124,7 +7092,7 @@
                 <a:solidFill>
                   <a:srgbClr val="198FD3"/>
                 </a:solidFill>
-                <a:latin typeface="Aptos"/>
+                <a:latin typeface="Arial"/>
                 <a:hlinkClick r:id="rId5"/>
               </a:rPr>
               <a:t>Open the study, HLD and requirements →</a:t>
@@ -7184,14 +7152,14 @@
     </a:clrScheme>
     <a:fontScheme name="Helvetica Neue">
       <a:majorFont>
-        <a:latin typeface="Helvetica Neue"/>
-        <a:ea typeface=""/>
-        <a:cs typeface=""/>
+        <a:latin typeface="Arial"/>
+        <a:ea typeface="Arial"/>
+        <a:cs typeface="Arial"/>
       </a:majorFont>
       <a:minorFont>
-        <a:latin typeface="Helvetica Neue"/>
-        <a:ea typeface=""/>
-        <a:cs typeface=""/>
+        <a:latin typeface="Arial"/>
+        <a:ea typeface="Arial"/>
+        <a:cs typeface="Arial"/>
       </a:minorFont>
     </a:fontScheme>
     <a:fmtScheme name="Office">
@@ -7405,108 +7373,108 @@
     </a:clrScheme>
     <a:fontScheme name="Office">
       <a:majorFont>
-        <a:latin typeface="Aptos Display" panose="02110004020202020204"/>
-        <a:ea typeface=""/>
-        <a:cs typeface=""/>
-        <a:font script="Jpan" typeface="游ゴシック Light"/>
-        <a:font script="Hang" typeface="맑은 고딕"/>
-        <a:font script="Hans" typeface="等线 Light"/>
-        <a:font script="Hant" typeface="新細明體"/>
-        <a:font script="Arab" typeface="Times New Roman"/>
-        <a:font script="Hebr" typeface="Times New Roman"/>
-        <a:font script="Thai" typeface="Angsana New"/>
-        <a:font script="Ethi" typeface="Nyala"/>
-        <a:font script="Beng" typeface="Vrinda"/>
-        <a:font script="Gujr" typeface="Shruti"/>
-        <a:font script="Khmr" typeface="MoolBoran"/>
-        <a:font script="Knda" typeface="Tunga"/>
-        <a:font script="Guru" typeface="Raavi"/>
-        <a:font script="Cans" typeface="Euphemia"/>
-        <a:font script="Cher" typeface="Plantagenet Cherokee"/>
-        <a:font script="Yiii" typeface="Microsoft Yi Baiti"/>
-        <a:font script="Tibt" typeface="Microsoft Himalaya"/>
-        <a:font script="Thaa" typeface="MV Boli"/>
-        <a:font script="Deva" typeface="Mangal"/>
-        <a:font script="Telu" typeface="Gautami"/>
-        <a:font script="Taml" typeface="Latha"/>
-        <a:font script="Syrc" typeface="Estrangelo Edessa"/>
-        <a:font script="Orya" typeface="Kalinga"/>
-        <a:font script="Mlym" typeface="Kartika"/>
-        <a:font script="Laoo" typeface="DokChampa"/>
-        <a:font script="Sinh" typeface="Iskoola Pota"/>
-        <a:font script="Mong" typeface="Mongolian Baiti"/>
-        <a:font script="Viet" typeface="Times New Roman"/>
-        <a:font script="Uigh" typeface="Microsoft Uighur"/>
-        <a:font script="Geor" typeface="Sylfaen"/>
+        <a:latin typeface="Arial"/>
+        <a:ea typeface="Arial"/>
+        <a:cs typeface="Arial"/>
+        <a:font script="Jpan" typeface="Arial"/>
+        <a:font script="Hang" typeface="Arial"/>
+        <a:font script="Hans" typeface="Arial"/>
+        <a:font script="Hant" typeface="Arial"/>
+        <a:font script="Arab" typeface="Arial"/>
+        <a:font script="Hebr" typeface="Arial"/>
+        <a:font script="Thai" typeface="Arial"/>
+        <a:font script="Ethi" typeface="Arial"/>
+        <a:font script="Beng" typeface="Arial"/>
+        <a:font script="Gujr" typeface="Arial"/>
+        <a:font script="Khmr" typeface="Arial"/>
+        <a:font script="Knda" typeface="Arial"/>
+        <a:font script="Guru" typeface="Arial"/>
+        <a:font script="Cans" typeface="Arial"/>
+        <a:font script="Cher" typeface="Arial"/>
+        <a:font script="Yiii" typeface="Arial"/>
+        <a:font script="Tibt" typeface="Arial"/>
+        <a:font script="Thaa" typeface="Arial"/>
+        <a:font script="Deva" typeface="Arial"/>
+        <a:font script="Telu" typeface="Arial"/>
+        <a:font script="Taml" typeface="Arial"/>
+        <a:font script="Syrc" typeface="Arial"/>
+        <a:font script="Orya" typeface="Arial"/>
+        <a:font script="Mlym" typeface="Arial"/>
+        <a:font script="Laoo" typeface="Arial"/>
+        <a:font script="Sinh" typeface="Arial"/>
+        <a:font script="Mong" typeface="Arial"/>
+        <a:font script="Viet" typeface="Arial"/>
+        <a:font script="Uigh" typeface="Arial"/>
+        <a:font script="Geor" typeface="Arial"/>
         <a:font script="Armn" typeface="Arial"/>
-        <a:font script="Bugi" typeface="Leelawadee UI"/>
-        <a:font script="Bopo" typeface="Microsoft JhengHei"/>
-        <a:font script="Java" typeface="Javanese Text"/>
-        <a:font script="Lisu" typeface="Segoe UI"/>
-        <a:font script="Mymr" typeface="Myanmar Text"/>
-        <a:font script="Nkoo" typeface="Ebrima"/>
-        <a:font script="Olck" typeface="Nirmala UI"/>
-        <a:font script="Osma" typeface="Ebrima"/>
-        <a:font script="Phag" typeface="Phagspa"/>
-        <a:font script="Syrn" typeface="Estrangelo Edessa"/>
-        <a:font script="Syrj" typeface="Estrangelo Edessa"/>
-        <a:font script="Syre" typeface="Estrangelo Edessa"/>
-        <a:font script="Sora" typeface="Nirmala UI"/>
-        <a:font script="Tale" typeface="Microsoft Tai Le"/>
-        <a:font script="Talu" typeface="Microsoft New Tai Lue"/>
-        <a:font script="Tfng" typeface="Ebrima"/>
+        <a:font script="Bugi" typeface="Arial"/>
+        <a:font script="Bopo" typeface="Arial"/>
+        <a:font script="Java" typeface="Arial"/>
+        <a:font script="Lisu" typeface="Arial"/>
+        <a:font script="Mymr" typeface="Arial"/>
+        <a:font script="Nkoo" typeface="Arial"/>
+        <a:font script="Olck" typeface="Arial"/>
+        <a:font script="Osma" typeface="Arial"/>
+        <a:font script="Phag" typeface="Arial"/>
+        <a:font script="Syrn" typeface="Arial"/>
+        <a:font script="Syrj" typeface="Arial"/>
+        <a:font script="Syre" typeface="Arial"/>
+        <a:font script="Sora" typeface="Arial"/>
+        <a:font script="Tale" typeface="Arial"/>
+        <a:font script="Talu" typeface="Arial"/>
+        <a:font script="Tfng" typeface="Arial"/>
       </a:majorFont>
       <a:minorFont>
-        <a:latin typeface="Aptos" panose="02110004020202020204"/>
-        <a:ea typeface=""/>
-        <a:cs typeface=""/>
-        <a:font script="Jpan" typeface="游ゴシック"/>
-        <a:font script="Hang" typeface="맑은 고딕"/>
-        <a:font script="Hans" typeface="等线"/>
-        <a:font script="Hant" typeface="新細明體"/>
+        <a:latin typeface="Arial"/>
+        <a:ea typeface="Arial"/>
+        <a:cs typeface="Arial"/>
+        <a:font script="Jpan" typeface="Arial"/>
+        <a:font script="Hang" typeface="Arial"/>
+        <a:font script="Hans" typeface="Arial"/>
+        <a:font script="Hant" typeface="Arial"/>
         <a:font script="Arab" typeface="Arial"/>
         <a:font script="Hebr" typeface="Arial"/>
-        <a:font script="Thai" typeface="Cordia New"/>
-        <a:font script="Ethi" typeface="Nyala"/>
-        <a:font script="Beng" typeface="Vrinda"/>
-        <a:font script="Gujr" typeface="Shruti"/>
-        <a:font script="Khmr" typeface="DaunPenh"/>
-        <a:font script="Knda" typeface="Tunga"/>
-        <a:font script="Guru" typeface="Raavi"/>
-        <a:font script="Cans" typeface="Euphemia"/>
-        <a:font script="Cher" typeface="Plantagenet Cherokee"/>
-        <a:font script="Yiii" typeface="Microsoft Yi Baiti"/>
-        <a:font script="Tibt" typeface="Microsoft Himalaya"/>
-        <a:font script="Thaa" typeface="MV Boli"/>
-        <a:font script="Deva" typeface="Mangal"/>
-        <a:font script="Telu" typeface="Gautami"/>
-        <a:font script="Taml" typeface="Latha"/>
-        <a:font script="Syrc" typeface="Estrangelo Edessa"/>
-        <a:font script="Orya" typeface="Kalinga"/>
-        <a:font script="Mlym" typeface="Kartika"/>
-        <a:font script="Laoo" typeface="DokChampa"/>
-        <a:font script="Sinh" typeface="Iskoola Pota"/>
-        <a:font script="Mong" typeface="Mongolian Baiti"/>
+        <a:font script="Thai" typeface="Arial"/>
+        <a:font script="Ethi" typeface="Arial"/>
+        <a:font script="Beng" typeface="Arial"/>
+        <a:font script="Gujr" typeface="Arial"/>
+        <a:font script="Khmr" typeface="Arial"/>
+        <a:font script="Knda" typeface="Arial"/>
+        <a:font script="Guru" typeface="Arial"/>
+        <a:font script="Cans" typeface="Arial"/>
+        <a:font script="Cher" typeface="Arial"/>
+        <a:font script="Yiii" typeface="Arial"/>
+        <a:font script="Tibt" typeface="Arial"/>
+        <a:font script="Thaa" typeface="Arial"/>
+        <a:font script="Deva" typeface="Arial"/>
+        <a:font script="Telu" typeface="Arial"/>
+        <a:font script="Taml" typeface="Arial"/>
+        <a:font script="Syrc" typeface="Arial"/>
+        <a:font script="Orya" typeface="Arial"/>
+        <a:font script="Mlym" typeface="Arial"/>
+        <a:font script="Laoo" typeface="Arial"/>
+        <a:font script="Sinh" typeface="Arial"/>
+        <a:font script="Mong" typeface="Arial"/>
         <a:font script="Viet" typeface="Arial"/>
-        <a:font script="Uigh" typeface="Microsoft Uighur"/>
-        <a:font script="Geor" typeface="Sylfaen"/>
+        <a:font script="Uigh" typeface="Arial"/>
+        <a:font script="Geor" typeface="Arial"/>
         <a:font script="Armn" typeface="Arial"/>
-        <a:font script="Bugi" typeface="Leelawadee UI"/>
-        <a:font script="Bopo" typeface="Microsoft JhengHei"/>
-        <a:font script="Java" typeface="Javanese Text"/>
-        <a:font script="Lisu" typeface="Segoe UI"/>
-        <a:font script="Mymr" typeface="Myanmar Text"/>
-        <a:font script="Nkoo" typeface="Ebrima"/>
-        <a:font script="Olck" typeface="Nirmala UI"/>
-        <a:font script="Osma" typeface="Ebrima"/>
-        <a:font script="Phag" typeface="Phagspa"/>
-        <a:font script="Syrn" typeface="Estrangelo Edessa"/>
-        <a:font script="Syrj" typeface="Estrangelo Edessa"/>
-        <a:font script="Syre" typeface="Estrangelo Edessa"/>
-        <a:font script="Sora" typeface="Nirmala UI"/>
-        <a:font script="Tale" typeface="Microsoft Tai Le"/>
-        <a:font script="Talu" typeface="Microsoft New Tai Lue"/>
-        <a:font script="Tfng" typeface="Ebrima"/>
+        <a:font script="Bugi" typeface="Arial"/>
+        <a:font script="Bopo" typeface="Arial"/>
+        <a:font script="Java" typeface="Arial"/>
+        <a:font script="Lisu" typeface="Arial"/>
+        <a:font script="Mymr" typeface="Arial"/>
+        <a:font script="Nkoo" typeface="Arial"/>
+        <a:font script="Olck" typeface="Arial"/>
+        <a:font script="Osma" typeface="Arial"/>
+        <a:font script="Phag" typeface="Arial"/>
+        <a:font script="Syrn" typeface="Arial"/>
+        <a:font script="Syrj" typeface="Arial"/>
+        <a:font script="Syre" typeface="Arial"/>
+        <a:font script="Sora" typeface="Arial"/>
+        <a:font script="Tale" typeface="Arial"/>
+        <a:font script="Talu" typeface="Arial"/>
+        <a:font script="Tfng" typeface="Arial"/>
       </a:minorFont>
     </a:fontScheme>
     <a:fmtScheme name="Office">

</xml_diff>